<commit_message>
Fix mobile login auto-signout issue by wrapping FCM token calls in nested try-catch
</commit_message>
<xml_diff>
--- a/ONEDROP_Presentation.pptx
+++ b/ONEDROP_Presentation.pptx
@@ -5,16 +5,16 @@
     <p:sldMasterId id="2147483648" r:id="rId1"/>
   </p:sldMasterIdLst>
   <p:sldIdLst>
-    <p:sldId id="256" r:id="rId7"/>
-    <p:sldId id="257" r:id="rId8"/>
-    <p:sldId id="258" r:id="rId9"/>
-    <p:sldId id="259" r:id="rId10"/>
-    <p:sldId id="260" r:id="rId11"/>
-    <p:sldId id="261" r:id="rId12"/>
-    <p:sldId id="262" r:id="rId13"/>
-    <p:sldId id="263" r:id="rId14"/>
+    <p:sldId id="256" r:id="rId2"/>
+    <p:sldId id="257" r:id="rId3"/>
+    <p:sldId id="258" r:id="rId4"/>
+    <p:sldId id="259" r:id="rId5"/>
+    <p:sldId id="260" r:id="rId6"/>
+    <p:sldId id="261" r:id="rId7"/>
+    <p:sldId id="262" r:id="rId8"/>
+    <p:sldId id="263" r:id="rId9"/>
   </p:sldIdLst>
-  <p:sldSz cx="12191695" cy="6858000" type="screen4x3"/>
+  <p:sldSz cx="12192000" cy="6858000"/>
   <p:notesSz cx="6858000" cy="9144000"/>
   <p:defaultTextStyle>
     <a:defPPr>
@@ -111,7 +111,75 @@
       </a:defRPr>
     </a:lvl9pPr>
   </p:defaultTextStyle>
+  <p:extLst>
+    <p:ext uri="{EFAFB233-063F-42B5-8137-9DF3F51BA10A}">
+      <p15:sldGuideLst xmlns:p15="http://schemas.microsoft.com/office/powerpoint/2012/main">
+        <p15:guide id="1" orient="horz" pos="2160">
+          <p15:clr>
+            <a:srgbClr val="A4A3A4"/>
+          </p15:clr>
+        </p15:guide>
+        <p15:guide id="2" pos="2880">
+          <p15:clr>
+            <a:srgbClr val="A4A3A4"/>
+          </p15:clr>
+        </p15:guide>
+      </p15:sldGuideLst>
+    </p:ext>
+  </p:extLst>
 </p:presentation>
+</file>
+
+<file path=ppt/revisionInfo.xml><?xml version="1.0" encoding="utf-8"?>
+<p1510:revInfo xmlns:a="http://schemas.openxmlformats.org/drawingml/2006/main" xmlns:r="http://schemas.openxmlformats.org/officeDocument/2006/relationships" xmlns:p1510="http://schemas.microsoft.com/office/powerpoint/2015/10/main">
+  <p1510:revLst>
+    <p1510:client id="{5AB72830-43FB-46D1-A7AB-6E8A3445D731}" v="1" dt="2026-06-05T18:46:41.619"/>
+  </p1510:revLst>
+</p1510:revInfo>
+</file>
+
+<file path=ppt/changesInfos/changesInfo1.xml><?xml version="1.0" encoding="utf-8"?>
+<pc:chgInfo xmlns:a="http://schemas.openxmlformats.org/drawingml/2006/main" xmlns:r="http://schemas.openxmlformats.org/officeDocument/2006/relationships" xmlns:ac="http://schemas.microsoft.com/office/drawing/2013/main/command" xmlns:pc="http://schemas.microsoft.com/office/powerpoint/2013/main/command">
+  <pc:docChgLst>
+    <pc:chgData name="Jagadeeswar Reddy" userId="bcd27d93f730bbc2" providerId="LiveId" clId="{126207CD-AAF5-497F-8790-0982E5FEAF21}"/>
+    <pc:docChg chg="modSld">
+      <pc:chgData name="Jagadeeswar Reddy" userId="bcd27d93f730bbc2" providerId="LiveId" clId="{126207CD-AAF5-497F-8790-0982E5FEAF21}" dt="2026-06-05T18:46:41.619" v="0"/>
+      <pc:docMkLst>
+        <pc:docMk/>
+      </pc:docMkLst>
+      <pc:sldChg chg="modSp">
+        <pc:chgData name="Jagadeeswar Reddy" userId="bcd27d93f730bbc2" providerId="LiveId" clId="{126207CD-AAF5-497F-8790-0982E5FEAF21}" dt="2026-06-05T18:46:41.619" v="0"/>
+        <pc:sldMkLst>
+          <pc:docMk/>
+          <pc:sldMk cId="0" sldId="256"/>
+        </pc:sldMkLst>
+        <pc:spChg chg="mod">
+          <ac:chgData name="Jagadeeswar Reddy" userId="bcd27d93f730bbc2" providerId="LiveId" clId="{126207CD-AAF5-497F-8790-0982E5FEAF21}" dt="2026-06-05T18:46:41.619" v="0"/>
+          <ac:spMkLst>
+            <pc:docMk/>
+            <pc:sldMk cId="0" sldId="256"/>
+            <ac:spMk id="3" creationId="{00000000-0000-0000-0000-000000000000}"/>
+          </ac:spMkLst>
+        </pc:spChg>
+      </pc:sldChg>
+      <pc:sldChg chg="modSp">
+        <pc:chgData name="Jagadeeswar Reddy" userId="bcd27d93f730bbc2" providerId="LiveId" clId="{126207CD-AAF5-497F-8790-0982E5FEAF21}" dt="2026-06-05T18:46:41.619" v="0"/>
+        <pc:sldMkLst>
+          <pc:docMk/>
+          <pc:sldMk cId="0" sldId="258"/>
+        </pc:sldMkLst>
+        <pc:spChg chg="mod">
+          <ac:chgData name="Jagadeeswar Reddy" userId="bcd27d93f730bbc2" providerId="LiveId" clId="{126207CD-AAF5-497F-8790-0982E5FEAF21}" dt="2026-06-05T18:46:41.619" v="0"/>
+          <ac:spMkLst>
+            <pc:docMk/>
+            <pc:sldMk cId="0" sldId="258"/>
+            <ac:spMk id="3" creationId="{00000000-0000-0000-0000-000000000000}"/>
+          </ac:spMkLst>
+        </pc:spChg>
+      </pc:sldChg>
+    </pc:docChg>
+  </pc:docChgLst>
+</pc:chgInfo>
 </file>
 
 <file path=ppt/slideLayouts/slideLayout1.xml><?xml version="1.0" encoding="utf-8"?>
@@ -152,10 +220,9 @@
           <a:lstStyle/>
           <a:p>
             <a:r>
-              <a:rPr lang="en-US" smtClean="0"/>
+              <a:rPr lang="en-US"/>
               <a:t>Click to edit Master title style</a:t>
             </a:r>
-            <a:endParaRPr lang="en-US"/>
           </a:p>
         </p:txBody>
       </p:sp>
@@ -271,10 +338,9 @@
           </a:lstStyle>
           <a:p>
             <a:r>
-              <a:rPr lang="en-US" smtClean="0"/>
+              <a:rPr lang="en-US"/>
               <a:t>Click to edit Master subtitle style</a:t>
             </a:r>
-            <a:endParaRPr lang="en-US"/>
           </a:p>
         </p:txBody>
       </p:sp>
@@ -295,7 +361,7 @@
           <a:p>
             <a:fld id="{5BCAD085-E8A6-8845-BD4E-CB4CCA059FC4}" type="datetimeFigureOut">
               <a:rPr lang="en-US" smtClean="0"/>
-              <a:t>1/27/13</a:t>
+              <a:t>6/6/2026</a:t>
             </a:fld>
             <a:endParaRPr lang="en-US"/>
           </a:p>
@@ -389,10 +455,9 @@
           <a:lstStyle/>
           <a:p>
             <a:r>
-              <a:rPr lang="en-US" smtClean="0"/>
+              <a:rPr lang="en-US"/>
               <a:t>Click to edit Master title style</a:t>
             </a:r>
-            <a:endParaRPr lang="en-US"/>
           </a:p>
         </p:txBody>
       </p:sp>
@@ -413,38 +478,37 @@
           <a:p>
             <a:pPr lvl="0"/>
             <a:r>
-              <a:rPr lang="en-US" smtClean="0"/>
+              <a:rPr lang="en-US"/>
               <a:t>Click to edit Master text styles</a:t>
             </a:r>
           </a:p>
           <a:p>
             <a:pPr lvl="1"/>
             <a:r>
-              <a:rPr lang="en-US" smtClean="0"/>
+              <a:rPr lang="en-US"/>
               <a:t>Second level</a:t>
             </a:r>
           </a:p>
           <a:p>
             <a:pPr lvl="2"/>
             <a:r>
-              <a:rPr lang="en-US" smtClean="0"/>
+              <a:rPr lang="en-US"/>
               <a:t>Third level</a:t>
             </a:r>
           </a:p>
           <a:p>
             <a:pPr lvl="3"/>
             <a:r>
-              <a:rPr lang="en-US" smtClean="0"/>
+              <a:rPr lang="en-US"/>
               <a:t>Fourth level</a:t>
             </a:r>
           </a:p>
           <a:p>
             <a:pPr lvl="4"/>
             <a:r>
-              <a:rPr lang="en-US" smtClean="0"/>
+              <a:rPr lang="en-US"/>
               <a:t>Fifth level</a:t>
             </a:r>
-            <a:endParaRPr lang="en-US"/>
           </a:p>
         </p:txBody>
       </p:sp>
@@ -465,7 +529,7 @@
           <a:p>
             <a:fld id="{5BCAD085-E8A6-8845-BD4E-CB4CCA059FC4}" type="datetimeFigureOut">
               <a:rPr lang="en-US" smtClean="0"/>
-              <a:t>1/27/13</a:t>
+              <a:t>6/6/2026</a:t>
             </a:fld>
             <a:endParaRPr lang="en-US"/>
           </a:p>
@@ -564,10 +628,9 @@
           <a:lstStyle/>
           <a:p>
             <a:r>
-              <a:rPr lang="en-US" smtClean="0"/>
+              <a:rPr lang="en-US"/>
               <a:t>Click to edit Master title style</a:t>
             </a:r>
-            <a:endParaRPr lang="en-US"/>
           </a:p>
         </p:txBody>
       </p:sp>
@@ -593,38 +656,37 @@
           <a:p>
             <a:pPr lvl="0"/>
             <a:r>
-              <a:rPr lang="en-US" smtClean="0"/>
+              <a:rPr lang="en-US"/>
               <a:t>Click to edit Master text styles</a:t>
             </a:r>
           </a:p>
           <a:p>
             <a:pPr lvl="1"/>
             <a:r>
-              <a:rPr lang="en-US" smtClean="0"/>
+              <a:rPr lang="en-US"/>
               <a:t>Second level</a:t>
             </a:r>
           </a:p>
           <a:p>
             <a:pPr lvl="2"/>
             <a:r>
-              <a:rPr lang="en-US" smtClean="0"/>
+              <a:rPr lang="en-US"/>
               <a:t>Third level</a:t>
             </a:r>
           </a:p>
           <a:p>
             <a:pPr lvl="3"/>
             <a:r>
-              <a:rPr lang="en-US" smtClean="0"/>
+              <a:rPr lang="en-US"/>
               <a:t>Fourth level</a:t>
             </a:r>
           </a:p>
           <a:p>
             <a:pPr lvl="4"/>
             <a:r>
-              <a:rPr lang="en-US" smtClean="0"/>
+              <a:rPr lang="en-US"/>
               <a:t>Fifth level</a:t>
             </a:r>
-            <a:endParaRPr lang="en-US"/>
           </a:p>
         </p:txBody>
       </p:sp>
@@ -645,7 +707,7 @@
           <a:p>
             <a:fld id="{5BCAD085-E8A6-8845-BD4E-CB4CCA059FC4}" type="datetimeFigureOut">
               <a:rPr lang="en-US" smtClean="0"/>
-              <a:t>1/27/13</a:t>
+              <a:t>6/6/2026</a:t>
             </a:fld>
             <a:endParaRPr lang="en-US"/>
           </a:p>
@@ -739,10 +801,9 @@
           <a:lstStyle/>
           <a:p>
             <a:r>
-              <a:rPr lang="en-US" smtClean="0"/>
+              <a:rPr lang="en-US"/>
               <a:t>Click to edit Master title style</a:t>
             </a:r>
-            <a:endParaRPr lang="en-US"/>
           </a:p>
         </p:txBody>
       </p:sp>
@@ -763,38 +824,37 @@
           <a:p>
             <a:pPr lvl="0"/>
             <a:r>
-              <a:rPr lang="en-US" smtClean="0"/>
+              <a:rPr lang="en-US"/>
               <a:t>Click to edit Master text styles</a:t>
             </a:r>
           </a:p>
           <a:p>
             <a:pPr lvl="1"/>
             <a:r>
-              <a:rPr lang="en-US" smtClean="0"/>
+              <a:rPr lang="en-US"/>
               <a:t>Second level</a:t>
             </a:r>
           </a:p>
           <a:p>
             <a:pPr lvl="2"/>
             <a:r>
-              <a:rPr lang="en-US" smtClean="0"/>
+              <a:rPr lang="en-US"/>
               <a:t>Third level</a:t>
             </a:r>
           </a:p>
           <a:p>
             <a:pPr lvl="3"/>
             <a:r>
-              <a:rPr lang="en-US" smtClean="0"/>
+              <a:rPr lang="en-US"/>
               <a:t>Fourth level</a:t>
             </a:r>
           </a:p>
           <a:p>
             <a:pPr lvl="4"/>
             <a:r>
-              <a:rPr lang="en-US" smtClean="0"/>
+              <a:rPr lang="en-US"/>
               <a:t>Fifth level</a:t>
             </a:r>
-            <a:endParaRPr lang="en-US"/>
           </a:p>
         </p:txBody>
       </p:sp>
@@ -815,7 +875,7 @@
           <a:p>
             <a:fld id="{5BCAD085-E8A6-8845-BD4E-CB4CCA059FC4}" type="datetimeFigureOut">
               <a:rPr lang="en-US" smtClean="0"/>
-              <a:t>1/27/13</a:t>
+              <a:t>6/6/2026</a:t>
             </a:fld>
             <a:endParaRPr lang="en-US"/>
           </a:p>
@@ -918,10 +978,9 @@
           </a:lstStyle>
           <a:p>
             <a:r>
-              <a:rPr lang="en-US" smtClean="0"/>
+              <a:rPr lang="en-US"/>
               <a:t>Click to edit Master title style</a:t>
             </a:r>
-            <a:endParaRPr lang="en-US"/>
           </a:p>
         </p:txBody>
       </p:sp>
@@ -1038,7 +1097,7 @@
           <a:p>
             <a:pPr lvl="0"/>
             <a:r>
-              <a:rPr lang="en-US" smtClean="0"/>
+              <a:rPr lang="en-US"/>
               <a:t>Click to edit Master text styles</a:t>
             </a:r>
           </a:p>
@@ -1061,7 +1120,7 @@
           <a:p>
             <a:fld id="{5BCAD085-E8A6-8845-BD4E-CB4CCA059FC4}" type="datetimeFigureOut">
               <a:rPr lang="en-US" smtClean="0"/>
-              <a:t>1/27/13</a:t>
+              <a:t>6/6/2026</a:t>
             </a:fld>
             <a:endParaRPr lang="en-US"/>
           </a:p>
@@ -1155,10 +1214,9 @@
           <a:lstStyle/>
           <a:p>
             <a:r>
-              <a:rPr lang="en-US" smtClean="0"/>
+              <a:rPr lang="en-US"/>
               <a:t>Click to edit Master title style</a:t>
             </a:r>
-            <a:endParaRPr lang="en-US"/>
           </a:p>
         </p:txBody>
       </p:sp>
@@ -1212,38 +1270,37 @@
           <a:p>
             <a:pPr lvl="0"/>
             <a:r>
-              <a:rPr lang="en-US" smtClean="0"/>
+              <a:rPr lang="en-US"/>
               <a:t>Click to edit Master text styles</a:t>
             </a:r>
           </a:p>
           <a:p>
             <a:pPr lvl="1"/>
             <a:r>
-              <a:rPr lang="en-US" smtClean="0"/>
+              <a:rPr lang="en-US"/>
               <a:t>Second level</a:t>
             </a:r>
           </a:p>
           <a:p>
             <a:pPr lvl="2"/>
             <a:r>
-              <a:rPr lang="en-US" smtClean="0"/>
+              <a:rPr lang="en-US"/>
               <a:t>Third level</a:t>
             </a:r>
           </a:p>
           <a:p>
             <a:pPr lvl="3"/>
             <a:r>
-              <a:rPr lang="en-US" smtClean="0"/>
+              <a:rPr lang="en-US"/>
               <a:t>Fourth level</a:t>
             </a:r>
           </a:p>
           <a:p>
             <a:pPr lvl="4"/>
             <a:r>
-              <a:rPr lang="en-US" smtClean="0"/>
+              <a:rPr lang="en-US"/>
               <a:t>Fifth level</a:t>
             </a:r>
-            <a:endParaRPr lang="en-US"/>
           </a:p>
         </p:txBody>
       </p:sp>
@@ -1297,38 +1354,37 @@
           <a:p>
             <a:pPr lvl="0"/>
             <a:r>
-              <a:rPr lang="en-US" smtClean="0"/>
+              <a:rPr lang="en-US"/>
               <a:t>Click to edit Master text styles</a:t>
             </a:r>
           </a:p>
           <a:p>
             <a:pPr lvl="1"/>
             <a:r>
-              <a:rPr lang="en-US" smtClean="0"/>
+              <a:rPr lang="en-US"/>
               <a:t>Second level</a:t>
             </a:r>
           </a:p>
           <a:p>
             <a:pPr lvl="2"/>
             <a:r>
-              <a:rPr lang="en-US" smtClean="0"/>
+              <a:rPr lang="en-US"/>
               <a:t>Third level</a:t>
             </a:r>
           </a:p>
           <a:p>
             <a:pPr lvl="3"/>
             <a:r>
-              <a:rPr lang="en-US" smtClean="0"/>
+              <a:rPr lang="en-US"/>
               <a:t>Fourth level</a:t>
             </a:r>
           </a:p>
           <a:p>
             <a:pPr lvl="4"/>
             <a:r>
-              <a:rPr lang="en-US" smtClean="0"/>
+              <a:rPr lang="en-US"/>
               <a:t>Fifth level</a:t>
             </a:r>
-            <a:endParaRPr lang="en-US"/>
           </a:p>
         </p:txBody>
       </p:sp>
@@ -1349,7 +1405,7 @@
           <a:p>
             <a:fld id="{5BCAD085-E8A6-8845-BD4E-CB4CCA059FC4}" type="datetimeFigureOut">
               <a:rPr lang="en-US" smtClean="0"/>
-              <a:t>1/27/13</a:t>
+              <a:t>6/6/2026</a:t>
             </a:fld>
             <a:endParaRPr lang="en-US"/>
           </a:p>
@@ -1447,10 +1503,9 @@
           </a:lstStyle>
           <a:p>
             <a:r>
-              <a:rPr lang="en-US" smtClean="0"/>
+              <a:rPr lang="en-US"/>
               <a:t>Click to edit Master title style</a:t>
             </a:r>
-            <a:endParaRPr lang="en-US"/>
           </a:p>
         </p:txBody>
       </p:sp>
@@ -1513,7 +1568,7 @@
           <a:p>
             <a:pPr lvl="0"/>
             <a:r>
-              <a:rPr lang="en-US" smtClean="0"/>
+              <a:rPr lang="en-US"/>
               <a:t>Click to edit Master text styles</a:t>
             </a:r>
           </a:p>
@@ -1569,38 +1624,37 @@
           <a:p>
             <a:pPr lvl="0"/>
             <a:r>
-              <a:rPr lang="en-US" smtClean="0"/>
+              <a:rPr lang="en-US"/>
               <a:t>Click to edit Master text styles</a:t>
             </a:r>
           </a:p>
           <a:p>
             <a:pPr lvl="1"/>
             <a:r>
-              <a:rPr lang="en-US" smtClean="0"/>
+              <a:rPr lang="en-US"/>
               <a:t>Second level</a:t>
             </a:r>
           </a:p>
           <a:p>
             <a:pPr lvl="2"/>
             <a:r>
-              <a:rPr lang="en-US" smtClean="0"/>
+              <a:rPr lang="en-US"/>
               <a:t>Third level</a:t>
             </a:r>
           </a:p>
           <a:p>
             <a:pPr lvl="3"/>
             <a:r>
-              <a:rPr lang="en-US" smtClean="0"/>
+              <a:rPr lang="en-US"/>
               <a:t>Fourth level</a:t>
             </a:r>
           </a:p>
           <a:p>
             <a:pPr lvl="4"/>
             <a:r>
-              <a:rPr lang="en-US" smtClean="0"/>
+              <a:rPr lang="en-US"/>
               <a:t>Fifth level</a:t>
             </a:r>
-            <a:endParaRPr lang="en-US"/>
           </a:p>
         </p:txBody>
       </p:sp>
@@ -1663,7 +1717,7 @@
           <a:p>
             <a:pPr lvl="0"/>
             <a:r>
-              <a:rPr lang="en-US" smtClean="0"/>
+              <a:rPr lang="en-US"/>
               <a:t>Click to edit Master text styles</a:t>
             </a:r>
           </a:p>
@@ -1719,38 +1773,37 @@
           <a:p>
             <a:pPr lvl="0"/>
             <a:r>
-              <a:rPr lang="en-US" smtClean="0"/>
+              <a:rPr lang="en-US"/>
               <a:t>Click to edit Master text styles</a:t>
             </a:r>
           </a:p>
           <a:p>
             <a:pPr lvl="1"/>
             <a:r>
-              <a:rPr lang="en-US" smtClean="0"/>
+              <a:rPr lang="en-US"/>
               <a:t>Second level</a:t>
             </a:r>
           </a:p>
           <a:p>
             <a:pPr lvl="2"/>
             <a:r>
-              <a:rPr lang="en-US" smtClean="0"/>
+              <a:rPr lang="en-US"/>
               <a:t>Third level</a:t>
             </a:r>
           </a:p>
           <a:p>
             <a:pPr lvl="3"/>
             <a:r>
-              <a:rPr lang="en-US" smtClean="0"/>
+              <a:rPr lang="en-US"/>
               <a:t>Fourth level</a:t>
             </a:r>
           </a:p>
           <a:p>
             <a:pPr lvl="4"/>
             <a:r>
-              <a:rPr lang="en-US" smtClean="0"/>
+              <a:rPr lang="en-US"/>
               <a:t>Fifth level</a:t>
             </a:r>
-            <a:endParaRPr lang="en-US"/>
           </a:p>
         </p:txBody>
       </p:sp>
@@ -1771,7 +1824,7 @@
           <a:p>
             <a:fld id="{5BCAD085-E8A6-8845-BD4E-CB4CCA059FC4}" type="datetimeFigureOut">
               <a:rPr lang="en-US" smtClean="0"/>
-              <a:t>1/27/13</a:t>
+              <a:t>6/6/2026</a:t>
             </a:fld>
             <a:endParaRPr lang="en-US"/>
           </a:p>
@@ -1865,10 +1918,9 @@
           <a:lstStyle/>
           <a:p>
             <a:r>
-              <a:rPr lang="en-US" smtClean="0"/>
+              <a:rPr lang="en-US"/>
               <a:t>Click to edit Master title style</a:t>
             </a:r>
-            <a:endParaRPr lang="en-US"/>
           </a:p>
         </p:txBody>
       </p:sp>
@@ -1889,7 +1941,7 @@
           <a:p>
             <a:fld id="{5BCAD085-E8A6-8845-BD4E-CB4CCA059FC4}" type="datetimeFigureOut">
               <a:rPr lang="en-US" smtClean="0"/>
-              <a:t>1/27/13</a:t>
+              <a:t>6/6/2026</a:t>
             </a:fld>
             <a:endParaRPr lang="en-US"/>
           </a:p>
@@ -1984,7 +2036,7 @@
           <a:p>
             <a:fld id="{5BCAD085-E8A6-8845-BD4E-CB4CCA059FC4}" type="datetimeFigureOut">
               <a:rPr lang="en-US" smtClean="0"/>
-              <a:t>1/27/13</a:t>
+              <a:t>6/6/2026</a:t>
             </a:fld>
             <a:endParaRPr lang="en-US"/>
           </a:p>
@@ -2087,10 +2139,9 @@
           </a:lstStyle>
           <a:p>
             <a:r>
-              <a:rPr lang="en-US" smtClean="0"/>
+              <a:rPr lang="en-US"/>
               <a:t>Click to edit Master title style</a:t>
             </a:r>
-            <a:endParaRPr lang="en-US"/>
           </a:p>
         </p:txBody>
       </p:sp>
@@ -2144,38 +2195,37 @@
           <a:p>
             <a:pPr lvl="0"/>
             <a:r>
-              <a:rPr lang="en-US" smtClean="0"/>
+              <a:rPr lang="en-US"/>
               <a:t>Click to edit Master text styles</a:t>
             </a:r>
           </a:p>
           <a:p>
             <a:pPr lvl="1"/>
             <a:r>
-              <a:rPr lang="en-US" smtClean="0"/>
+              <a:rPr lang="en-US"/>
               <a:t>Second level</a:t>
             </a:r>
           </a:p>
           <a:p>
             <a:pPr lvl="2"/>
             <a:r>
-              <a:rPr lang="en-US" smtClean="0"/>
+              <a:rPr lang="en-US"/>
               <a:t>Third level</a:t>
             </a:r>
           </a:p>
           <a:p>
             <a:pPr lvl="3"/>
             <a:r>
-              <a:rPr lang="en-US" smtClean="0"/>
+              <a:rPr lang="en-US"/>
               <a:t>Fourth level</a:t>
             </a:r>
           </a:p>
           <a:p>
             <a:pPr lvl="4"/>
             <a:r>
-              <a:rPr lang="en-US" smtClean="0"/>
+              <a:rPr lang="en-US"/>
               <a:t>Fifth level</a:t>
             </a:r>
-            <a:endParaRPr lang="en-US"/>
           </a:p>
         </p:txBody>
       </p:sp>
@@ -2238,7 +2288,7 @@
           <a:p>
             <a:pPr lvl="0"/>
             <a:r>
-              <a:rPr lang="en-US" smtClean="0"/>
+              <a:rPr lang="en-US"/>
               <a:t>Click to edit Master text styles</a:t>
             </a:r>
           </a:p>
@@ -2261,7 +2311,7 @@
           <a:p>
             <a:fld id="{5BCAD085-E8A6-8845-BD4E-CB4CCA059FC4}" type="datetimeFigureOut">
               <a:rPr lang="en-US" smtClean="0"/>
-              <a:t>1/27/13</a:t>
+              <a:t>6/6/2026</a:t>
             </a:fld>
             <a:endParaRPr lang="en-US"/>
           </a:p>
@@ -2364,10 +2414,9 @@
           </a:lstStyle>
           <a:p>
             <a:r>
-              <a:rPr lang="en-US" smtClean="0"/>
+              <a:rPr lang="en-US"/>
               <a:t>Click to edit Master title style</a:t>
             </a:r>
-            <a:endParaRPr lang="en-US"/>
           </a:p>
         </p:txBody>
       </p:sp>
@@ -2491,7 +2540,7 @@
           <a:p>
             <a:pPr lvl="0"/>
             <a:r>
-              <a:rPr lang="en-US" smtClean="0"/>
+              <a:rPr lang="en-US"/>
               <a:t>Click to edit Master text styles</a:t>
             </a:r>
           </a:p>
@@ -2514,7 +2563,7 @@
           <a:p>
             <a:fld id="{5BCAD085-E8A6-8845-BD4E-CB4CCA059FC4}" type="datetimeFigureOut">
               <a:rPr lang="en-US" smtClean="0"/>
-              <a:t>1/27/13</a:t>
+              <a:t>6/6/2026</a:t>
             </a:fld>
             <a:endParaRPr lang="en-US"/>
           </a:p>
@@ -2623,10 +2672,9 @@
           <a:lstStyle/>
           <a:p>
             <a:r>
-              <a:rPr lang="en-US" smtClean="0"/>
+              <a:rPr lang="en-US"/>
               <a:t>Click to edit Master title style</a:t>
             </a:r>
-            <a:endParaRPr lang="en-US"/>
           </a:p>
         </p:txBody>
       </p:sp>
@@ -2657,38 +2705,37 @@
           <a:p>
             <a:pPr lvl="0"/>
             <a:r>
-              <a:rPr lang="en-US" smtClean="0"/>
+              <a:rPr lang="en-US"/>
               <a:t>Click to edit Master text styles</a:t>
             </a:r>
           </a:p>
           <a:p>
             <a:pPr lvl="1"/>
             <a:r>
-              <a:rPr lang="en-US" smtClean="0"/>
+              <a:rPr lang="en-US"/>
               <a:t>Second level</a:t>
             </a:r>
           </a:p>
           <a:p>
             <a:pPr lvl="2"/>
             <a:r>
-              <a:rPr lang="en-US" smtClean="0"/>
+              <a:rPr lang="en-US"/>
               <a:t>Third level</a:t>
             </a:r>
           </a:p>
           <a:p>
             <a:pPr lvl="3"/>
             <a:r>
-              <a:rPr lang="en-US" smtClean="0"/>
+              <a:rPr lang="en-US"/>
               <a:t>Fourth level</a:t>
             </a:r>
           </a:p>
           <a:p>
             <a:pPr lvl="4"/>
             <a:r>
-              <a:rPr lang="en-US" smtClean="0"/>
+              <a:rPr lang="en-US"/>
               <a:t>Fifth level</a:t>
             </a:r>
-            <a:endParaRPr lang="en-US"/>
           </a:p>
         </p:txBody>
       </p:sp>
@@ -2727,7 +2774,7 @@
           <a:p>
             <a:fld id="{5BCAD085-E8A6-8845-BD4E-CB4CCA059FC4}" type="datetimeFigureOut">
               <a:rPr lang="en-US" smtClean="0"/>
-              <a:t>1/27/13</a:t>
+              <a:t>6/6/2026</a:t>
             </a:fld>
             <a:endParaRPr lang="en-US"/>
           </a:p>
@@ -3086,7 +3133,7 @@
 </file>
 
 <file path=ppt/slides/slide1.xml><?xml version="1.0" encoding="utf-8"?>
-<p:sld xmlns:a="http://schemas.openxmlformats.org/drawingml/2006/main" xmlns:p="http://schemas.openxmlformats.org/presentationml/2006/main" xmlns:r="http://schemas.openxmlformats.org/officeDocument/2006/relationships">
+<p:sld xmlns:a="http://schemas.openxmlformats.org/drawingml/2006/main" xmlns:r="http://schemas.openxmlformats.org/officeDocument/2006/relationships" xmlns:p="http://schemas.openxmlformats.org/presentationml/2006/main">
   <p:cSld>
     <p:bg>
       <p:bgPr>
@@ -3102,7 +3149,14 @@
         <p:cNvGrpSpPr/>
         <p:nvPr/>
       </p:nvGrpSpPr>
-      <p:grpSpPr/>
+      <p:grpSpPr>
+        <a:xfrm>
+          <a:off x="0" y="0"/>
+          <a:ext cx="0" cy="0"/>
+          <a:chOff x="0" y="0"/>
+          <a:chExt cx="0" cy="0"/>
+        </a:xfrm>
+      </p:grpSpPr>
       <p:sp>
         <p:nvSpPr>
           <p:cNvPr id="2" name="Rectangle 1"/>
@@ -3143,6 +3197,7 @@
           <a:lstStyle/>
           <a:p>
             <a:pPr algn="ctr"/>
+            <a:endParaRPr/>
           </a:p>
         </p:txBody>
       </p:sp>
@@ -3155,7 +3210,7 @@
         <p:spPr>
           <a:xfrm>
             <a:off x="1097280" y="2011680"/>
-            <a:ext cx="10058400" cy="3657600"/>
+            <a:ext cx="10058400" cy="2185214"/>
           </a:xfrm>
           <a:prstGeom prst="rect">
             <a:avLst/>
@@ -3169,14 +3224,20 @@
           <a:lstStyle/>
           <a:p>
             <a:r>
-              <a:rPr sz="6400" b="1">
+              <a:rPr lang="en-GB" sz="6400" b="1" dirty="0" err="1">
                 <a:solidFill>
                   <a:srgbClr val="FFFFFF"/>
                 </a:solidFill>
                 <a:latin typeface="Arial"/>
               </a:rPr>
-              <a:t>RAKTSETU</a:t>
-            </a:r>
+              <a:t>onedrop</a:t>
+            </a:r>
+            <a:endParaRPr sz="6400" b="1" dirty="0">
+              <a:solidFill>
+                <a:srgbClr val="FFFFFF"/>
+              </a:solidFill>
+              <a:latin typeface="Arial"/>
+            </a:endParaRPr>
           </a:p>
           <a:p>
             <a:pPr>
@@ -3185,7 +3246,7 @@
               </a:spcBef>
             </a:pPr>
             <a:r>
-              <a:rPr sz="2000" b="1">
+              <a:rPr sz="2000" b="1" dirty="0">
                 <a:solidFill>
                   <a:srgbClr val="EF4444"/>
                 </a:solidFill>
@@ -3201,7 +3262,7 @@
               </a:spcBef>
             </a:pPr>
             <a:r>
-              <a:rPr sz="1400">
+              <a:rPr sz="1400" dirty="0">
                 <a:solidFill>
                   <a:srgbClr val="94A3B8"/>
                 </a:solidFill>
@@ -3255,7 +3316,7 @@
 </file>
 
 <file path=ppt/slides/slide2.xml><?xml version="1.0" encoding="utf-8"?>
-<p:sld xmlns:a="http://schemas.openxmlformats.org/drawingml/2006/main" xmlns:p="http://schemas.openxmlformats.org/presentationml/2006/main" xmlns:r="http://schemas.openxmlformats.org/officeDocument/2006/relationships">
+<p:sld xmlns:a="http://schemas.openxmlformats.org/drawingml/2006/main" xmlns:r="http://schemas.openxmlformats.org/officeDocument/2006/relationships" xmlns:p="http://schemas.openxmlformats.org/presentationml/2006/main">
   <p:cSld>
     <p:bg>
       <p:bgPr>
@@ -3271,7 +3332,14 @@
         <p:cNvGrpSpPr/>
         <p:nvPr/>
       </p:nvGrpSpPr>
-      <p:grpSpPr/>
+      <p:grpSpPr>
+        <a:xfrm>
+          <a:off x="0" y="0"/>
+          <a:ext cx="0" cy="0"/>
+          <a:chOff x="0" y="0"/>
+          <a:chExt cx="0" cy="0"/>
+        </a:xfrm>
+      </p:grpSpPr>
       <p:sp>
         <p:nvSpPr>
           <p:cNvPr id="2" name="TextBox 1"/>
@@ -3382,6 +3450,7 @@
           <a:lstStyle/>
           <a:p>
             <a:pPr algn="ctr"/>
+            <a:endParaRPr/>
           </a:p>
         </p:txBody>
       </p:sp>
@@ -3425,6 +3494,7 @@
           <a:lstStyle/>
           <a:p>
             <a:pPr algn="ctr"/>
+            <a:endParaRPr/>
           </a:p>
         </p:txBody>
       </p:sp>
@@ -3536,6 +3606,7 @@
           <a:lstStyle/>
           <a:p>
             <a:pPr algn="ctr"/>
+            <a:endParaRPr/>
           </a:p>
         </p:txBody>
       </p:sp>
@@ -3579,6 +3650,7 @@
           <a:lstStyle/>
           <a:p>
             <a:pPr algn="ctr"/>
+            <a:endParaRPr/>
           </a:p>
         </p:txBody>
       </p:sp>
@@ -3690,6 +3762,7 @@
           <a:lstStyle/>
           <a:p>
             <a:pPr algn="ctr"/>
+            <a:endParaRPr/>
           </a:p>
         </p:txBody>
       </p:sp>
@@ -3733,6 +3806,7 @@
           <a:lstStyle/>
           <a:p>
             <a:pPr algn="ctr"/>
+            <a:endParaRPr/>
           </a:p>
         </p:txBody>
       </p:sp>
@@ -3811,7 +3885,7 @@
 </file>
 
 <file path=ppt/slides/slide3.xml><?xml version="1.0" encoding="utf-8"?>
-<p:sld xmlns:a="http://schemas.openxmlformats.org/drawingml/2006/main" xmlns:p="http://schemas.openxmlformats.org/presentationml/2006/main" xmlns:r="http://schemas.openxmlformats.org/officeDocument/2006/relationships">
+<p:sld xmlns:a="http://schemas.openxmlformats.org/drawingml/2006/main" xmlns:r="http://schemas.openxmlformats.org/officeDocument/2006/relationships" xmlns:p="http://schemas.openxmlformats.org/presentationml/2006/main">
   <p:cSld>
     <p:bg>
       <p:bgPr>
@@ -3827,7 +3901,14 @@
         <p:cNvGrpSpPr/>
         <p:nvPr/>
       </p:nvGrpSpPr>
-      <p:grpSpPr/>
+      <p:grpSpPr>
+        <a:xfrm>
+          <a:off x="0" y="0"/>
+          <a:ext cx="0" cy="0"/>
+          <a:chOff x="0" y="0"/>
+          <a:chExt cx="0" cy="0"/>
+        </a:xfrm>
+      </p:grpSpPr>
       <p:sp>
         <p:nvSpPr>
           <p:cNvPr id="2" name="TextBox 1"/>
@@ -3871,7 +3952,7 @@
         <p:spPr>
           <a:xfrm>
             <a:off x="731520" y="594360"/>
-            <a:ext cx="10728655" cy="731520"/>
+            <a:ext cx="10728655" cy="430887"/>
           </a:xfrm>
           <a:prstGeom prst="rect">
             <a:avLst/>
@@ -3885,13 +3966,22 @@
           <a:lstStyle/>
           <a:p>
             <a:r>
-              <a:rPr sz="2800" b="1">
+              <a:rPr lang="en-GB" sz="2800" b="1" dirty="0" err="1">
                 <a:solidFill>
                   <a:srgbClr val="FFFFFF"/>
                 </a:solidFill>
                 <a:latin typeface="Arial"/>
               </a:rPr>
-              <a:t>RaktSetu: The Intelligent Blood Bridge</a:t>
+              <a:t>onedrop</a:t>
+            </a:r>
+            <a:r>
+              <a:rPr sz="2800" b="1" dirty="0">
+                <a:solidFill>
+                  <a:srgbClr val="FFFFFF"/>
+                </a:solidFill>
+                <a:latin typeface="Arial"/>
+              </a:rPr>
+              <a:t>: The Intelligent Blood Bridge</a:t>
             </a:r>
           </a:p>
         </p:txBody>
@@ -3938,6 +4028,7 @@
           <a:lstStyle/>
           <a:p>
             <a:pPr algn="ctr"/>
+            <a:endParaRPr/>
           </a:p>
         </p:txBody>
       </p:sp>
@@ -3981,6 +4072,7 @@
           <a:lstStyle/>
           <a:p>
             <a:pPr algn="ctr"/>
+            <a:endParaRPr/>
           </a:p>
         </p:txBody>
       </p:sp>
@@ -4092,6 +4184,7 @@
           <a:lstStyle/>
           <a:p>
             <a:pPr algn="ctr"/>
+            <a:endParaRPr/>
           </a:p>
         </p:txBody>
       </p:sp>
@@ -4135,6 +4228,7 @@
           <a:lstStyle/>
           <a:p>
             <a:pPr algn="ctr"/>
+            <a:endParaRPr/>
           </a:p>
         </p:txBody>
       </p:sp>
@@ -4246,6 +4340,7 @@
           <a:lstStyle/>
           <a:p>
             <a:pPr algn="ctr"/>
+            <a:endParaRPr/>
           </a:p>
         </p:txBody>
       </p:sp>
@@ -4289,6 +4384,7 @@
           <a:lstStyle/>
           <a:p>
             <a:pPr algn="ctr"/>
+            <a:endParaRPr/>
           </a:p>
         </p:txBody>
       </p:sp>
@@ -4400,6 +4496,7 @@
           <a:lstStyle/>
           <a:p>
             <a:pPr algn="ctr"/>
+            <a:endParaRPr/>
           </a:p>
         </p:txBody>
       </p:sp>
@@ -4443,6 +4540,7 @@
           <a:lstStyle/>
           <a:p>
             <a:pPr algn="ctr"/>
+            <a:endParaRPr/>
           </a:p>
         </p:txBody>
       </p:sp>
@@ -4521,7 +4619,7 @@
 </file>
 
 <file path=ppt/slides/slide4.xml><?xml version="1.0" encoding="utf-8"?>
-<p:sld xmlns:a="http://schemas.openxmlformats.org/drawingml/2006/main" xmlns:p="http://schemas.openxmlformats.org/presentationml/2006/main" xmlns:r="http://schemas.openxmlformats.org/officeDocument/2006/relationships">
+<p:sld xmlns:a="http://schemas.openxmlformats.org/drawingml/2006/main" xmlns:r="http://schemas.openxmlformats.org/officeDocument/2006/relationships" xmlns:p="http://schemas.openxmlformats.org/presentationml/2006/main">
   <p:cSld>
     <p:bg>
       <p:bgPr>
@@ -4537,7 +4635,14 @@
         <p:cNvGrpSpPr/>
         <p:nvPr/>
       </p:nvGrpSpPr>
-      <p:grpSpPr/>
+      <p:grpSpPr>
+        <a:xfrm>
+          <a:off x="0" y="0"/>
+          <a:ext cx="0" cy="0"/>
+          <a:chOff x="0" y="0"/>
+          <a:chExt cx="0" cy="0"/>
+        </a:xfrm>
+      </p:grpSpPr>
       <p:sp>
         <p:nvSpPr>
           <p:cNvPr id="2" name="TextBox 1"/>
@@ -4648,6 +4753,7 @@
           <a:lstStyle/>
           <a:p>
             <a:pPr algn="ctr"/>
+            <a:endParaRPr/>
           </a:p>
         </p:txBody>
       </p:sp>
@@ -4691,6 +4797,7 @@
           <a:lstStyle/>
           <a:p>
             <a:pPr algn="ctr"/>
+            <a:endParaRPr/>
           </a:p>
         </p:txBody>
       </p:sp>
@@ -4795,6 +4902,7 @@
           <a:lstStyle/>
           <a:p>
             <a:pPr algn="ctr"/>
+            <a:endParaRPr/>
           </a:p>
         </p:txBody>
       </p:sp>
@@ -4838,6 +4946,7 @@
           <a:lstStyle/>
           <a:p>
             <a:pPr algn="ctr"/>
+            <a:endParaRPr/>
           </a:p>
         </p:txBody>
       </p:sp>
@@ -4942,6 +5051,7 @@
           <a:lstStyle/>
           <a:p>
             <a:pPr algn="ctr"/>
+            <a:endParaRPr/>
           </a:p>
         </p:txBody>
       </p:sp>
@@ -4985,6 +5095,7 @@
           <a:lstStyle/>
           <a:p>
             <a:pPr algn="ctr"/>
+            <a:endParaRPr/>
           </a:p>
         </p:txBody>
       </p:sp>
@@ -5089,6 +5200,7 @@
           <a:lstStyle/>
           <a:p>
             <a:pPr algn="ctr"/>
+            <a:endParaRPr/>
           </a:p>
         </p:txBody>
       </p:sp>
@@ -5132,6 +5244,7 @@
           <a:lstStyle/>
           <a:p>
             <a:pPr algn="ctr"/>
+            <a:endParaRPr/>
           </a:p>
         </p:txBody>
       </p:sp>
@@ -5203,7 +5316,7 @@
 </file>
 
 <file path=ppt/slides/slide5.xml><?xml version="1.0" encoding="utf-8"?>
-<p:sld xmlns:a="http://schemas.openxmlformats.org/drawingml/2006/main" xmlns:p="http://schemas.openxmlformats.org/presentationml/2006/main" xmlns:r="http://schemas.openxmlformats.org/officeDocument/2006/relationships">
+<p:sld xmlns:a="http://schemas.openxmlformats.org/drawingml/2006/main" xmlns:r="http://schemas.openxmlformats.org/officeDocument/2006/relationships" xmlns:p="http://schemas.openxmlformats.org/presentationml/2006/main">
   <p:cSld>
     <p:bg>
       <p:bgPr>
@@ -5219,7 +5332,14 @@
         <p:cNvGrpSpPr/>
         <p:nvPr/>
       </p:nvGrpSpPr>
-      <p:grpSpPr/>
+      <p:grpSpPr>
+        <a:xfrm>
+          <a:off x="0" y="0"/>
+          <a:ext cx="0" cy="0"/>
+          <a:chOff x="0" y="0"/>
+          <a:chExt cx="0" cy="0"/>
+        </a:xfrm>
+      </p:grpSpPr>
       <p:sp>
         <p:nvSpPr>
           <p:cNvPr id="2" name="TextBox 1"/>
@@ -5330,6 +5450,7 @@
           <a:lstStyle/>
           <a:p>
             <a:pPr algn="ctr"/>
+            <a:endParaRPr/>
           </a:p>
         </p:txBody>
       </p:sp>
@@ -5373,6 +5494,7 @@
           <a:lstStyle/>
           <a:p>
             <a:pPr algn="ctr"/>
+            <a:endParaRPr/>
           </a:p>
         </p:txBody>
       </p:sp>
@@ -5548,6 +5670,7 @@
           <a:lstStyle/>
           <a:p>
             <a:pPr algn="ctr"/>
+            <a:endParaRPr/>
           </a:p>
         </p:txBody>
       </p:sp>
@@ -5591,6 +5714,7 @@
           <a:lstStyle/>
           <a:p>
             <a:pPr algn="ctr"/>
+            <a:endParaRPr/>
           </a:p>
         </p:txBody>
       </p:sp>
@@ -5766,6 +5890,7 @@
           <a:lstStyle/>
           <a:p>
             <a:pPr algn="ctr"/>
+            <a:endParaRPr/>
           </a:p>
         </p:txBody>
       </p:sp>
@@ -5809,6 +5934,7 @@
           <a:lstStyle/>
           <a:p>
             <a:pPr algn="ctr"/>
+            <a:endParaRPr/>
           </a:p>
         </p:txBody>
       </p:sp>
@@ -5951,7 +6077,7 @@
 </file>
 
 <file path=ppt/slides/slide6.xml><?xml version="1.0" encoding="utf-8"?>
-<p:sld xmlns:a="http://schemas.openxmlformats.org/drawingml/2006/main" xmlns:p="http://schemas.openxmlformats.org/presentationml/2006/main" xmlns:r="http://schemas.openxmlformats.org/officeDocument/2006/relationships">
+<p:sld xmlns:a="http://schemas.openxmlformats.org/drawingml/2006/main" xmlns:r="http://schemas.openxmlformats.org/officeDocument/2006/relationships" xmlns:p="http://schemas.openxmlformats.org/presentationml/2006/main">
   <p:cSld>
     <p:bg>
       <p:bgPr>
@@ -5967,7 +6093,14 @@
         <p:cNvGrpSpPr/>
         <p:nvPr/>
       </p:nvGrpSpPr>
-      <p:grpSpPr/>
+      <p:grpSpPr>
+        <a:xfrm>
+          <a:off x="0" y="0"/>
+          <a:ext cx="0" cy="0"/>
+          <a:chOff x="0" y="0"/>
+          <a:chExt cx="0" cy="0"/>
+        </a:xfrm>
+      </p:grpSpPr>
       <p:sp>
         <p:nvSpPr>
           <p:cNvPr id="2" name="TextBox 1"/>
@@ -6078,6 +6211,7 @@
           <a:lstStyle/>
           <a:p>
             <a:pPr algn="ctr"/>
+            <a:endParaRPr/>
           </a:p>
         </p:txBody>
       </p:sp>
@@ -6121,6 +6255,7 @@
           <a:lstStyle/>
           <a:p>
             <a:pPr algn="ctr"/>
+            <a:endParaRPr/>
           </a:p>
         </p:txBody>
       </p:sp>
@@ -6163,7 +6298,7 @@
               </a:spcBef>
             </a:pPr>
             <a:r>
-              <a:rPr b="1" sz="1200">
+              <a:rPr sz="1200" b="1">
                 <a:solidFill>
                   <a:srgbClr val="EF4444"/>
                 </a:solidFill>
@@ -6186,7 +6321,7 @@
               </a:spcBef>
             </a:pPr>
             <a:r>
-              <a:rPr b="1" sz="1200">
+              <a:rPr sz="1200" b="1">
                 <a:solidFill>
                   <a:srgbClr val="EF4444"/>
                 </a:solidFill>
@@ -6209,7 +6344,7 @@
               </a:spcBef>
             </a:pPr>
             <a:r>
-              <a:rPr b="1" sz="1200">
+              <a:rPr sz="1200" b="1">
                 <a:solidFill>
                   <a:srgbClr val="EF4444"/>
                 </a:solidFill>
@@ -6232,7 +6367,7 @@
               </a:spcBef>
             </a:pPr>
             <a:r>
-              <a:rPr b="1" sz="1200">
+              <a:rPr sz="1200" b="1">
                 <a:solidFill>
                   <a:srgbClr val="EF4444"/>
                 </a:solidFill>
@@ -6292,6 +6427,7 @@
           <a:lstStyle/>
           <a:p>
             <a:pPr algn="ctr"/>
+            <a:endParaRPr/>
           </a:p>
         </p:txBody>
       </p:sp>
@@ -6335,6 +6471,7 @@
           <a:lstStyle/>
           <a:p>
             <a:pPr algn="ctr"/>
+            <a:endParaRPr/>
           </a:p>
         </p:txBody>
       </p:sp>
@@ -6377,7 +6514,7 @@
               </a:spcBef>
             </a:pPr>
             <a:r>
-              <a:rPr b="1" sz="1200">
+              <a:rPr sz="1200" b="1">
                 <a:solidFill>
                   <a:srgbClr val="10B981"/>
                 </a:solidFill>
@@ -6400,7 +6537,7 @@
               </a:spcBef>
             </a:pPr>
             <a:r>
-              <a:rPr b="1" sz="1200">
+              <a:rPr sz="1200" b="1">
                 <a:solidFill>
                   <a:srgbClr val="10B981"/>
                 </a:solidFill>
@@ -6423,7 +6560,7 @@
               </a:spcBef>
             </a:pPr>
             <a:r>
-              <a:rPr b="1" sz="1200">
+              <a:rPr sz="1200" b="1">
                 <a:solidFill>
                   <a:srgbClr val="10B981"/>
                 </a:solidFill>
@@ -6446,7 +6583,7 @@
               </a:spcBef>
             </a:pPr>
             <a:r>
-              <a:rPr b="1" sz="1200">
+              <a:rPr sz="1200" b="1">
                 <a:solidFill>
                   <a:srgbClr val="10B981"/>
                 </a:solidFill>
@@ -6473,7 +6610,7 @@
 </file>
 
 <file path=ppt/slides/slide7.xml><?xml version="1.0" encoding="utf-8"?>
-<p:sld xmlns:a="http://schemas.openxmlformats.org/drawingml/2006/main" xmlns:p="http://schemas.openxmlformats.org/presentationml/2006/main" xmlns:r="http://schemas.openxmlformats.org/officeDocument/2006/relationships">
+<p:sld xmlns:a="http://schemas.openxmlformats.org/drawingml/2006/main" xmlns:r="http://schemas.openxmlformats.org/officeDocument/2006/relationships" xmlns:p="http://schemas.openxmlformats.org/presentationml/2006/main">
   <p:cSld>
     <p:bg>
       <p:bgPr>
@@ -6489,7 +6626,14 @@
         <p:cNvGrpSpPr/>
         <p:nvPr/>
       </p:nvGrpSpPr>
-      <p:grpSpPr/>
+      <p:grpSpPr>
+        <a:xfrm>
+          <a:off x="0" y="0"/>
+          <a:ext cx="0" cy="0"/>
+          <a:chOff x="0" y="0"/>
+          <a:chExt cx="0" cy="0"/>
+        </a:xfrm>
+      </p:grpSpPr>
       <p:sp>
         <p:nvSpPr>
           <p:cNvPr id="2" name="TextBox 1"/>
@@ -6600,6 +6744,7 @@
           <a:lstStyle/>
           <a:p>
             <a:pPr algn="ctr"/>
+            <a:endParaRPr/>
           </a:p>
         </p:txBody>
       </p:sp>
@@ -6643,6 +6788,7 @@
           <a:lstStyle/>
           <a:p>
             <a:pPr algn="ctr"/>
+            <a:endParaRPr/>
           </a:p>
         </p:txBody>
       </p:sp>
@@ -6685,7 +6831,7 @@
               </a:spcBef>
             </a:pPr>
             <a:r>
-              <a:rPr b="1" sz="1350">
+              <a:rPr sz="1350" b="1">
                 <a:solidFill>
                   <a:srgbClr val="F59E0B"/>
                 </a:solidFill>
@@ -6708,7 +6854,7 @@
               </a:spcBef>
             </a:pPr>
             <a:r>
-              <a:rPr b="1" sz="1350">
+              <a:rPr sz="1350" b="1">
                 <a:solidFill>
                   <a:srgbClr val="F59E0B"/>
                 </a:solidFill>
@@ -6731,7 +6877,7 @@
               </a:spcBef>
             </a:pPr>
             <a:r>
-              <a:rPr b="1" sz="1350">
+              <a:rPr sz="1350" b="1">
                 <a:solidFill>
                   <a:srgbClr val="F59E0B"/>
                 </a:solidFill>
@@ -6754,7 +6900,7 @@
               </a:spcBef>
             </a:pPr>
             <a:r>
-              <a:rPr b="1" sz="1350">
+              <a:rPr sz="1350" b="1">
                 <a:solidFill>
                   <a:srgbClr val="F59E0B"/>
                 </a:solidFill>
@@ -6781,7 +6927,7 @@
 </file>
 
 <file path=ppt/slides/slide8.xml><?xml version="1.0" encoding="utf-8"?>
-<p:sld xmlns:a="http://schemas.openxmlformats.org/drawingml/2006/main" xmlns:p="http://schemas.openxmlformats.org/presentationml/2006/main" xmlns:r="http://schemas.openxmlformats.org/officeDocument/2006/relationships">
+<p:sld xmlns:a="http://schemas.openxmlformats.org/drawingml/2006/main" xmlns:r="http://schemas.openxmlformats.org/officeDocument/2006/relationships" xmlns:p="http://schemas.openxmlformats.org/presentationml/2006/main">
   <p:cSld>
     <p:bg>
       <p:bgPr>
@@ -6797,7 +6943,14 @@
         <p:cNvGrpSpPr/>
         <p:nvPr/>
       </p:nvGrpSpPr>
-      <p:grpSpPr/>
+      <p:grpSpPr>
+        <a:xfrm>
+          <a:off x="0" y="0"/>
+          <a:ext cx="0" cy="0"/>
+          <a:chOff x="0" y="0"/>
+          <a:chExt cx="0" cy="0"/>
+        </a:xfrm>
+      </p:grpSpPr>
       <p:sp>
         <p:nvSpPr>
           <p:cNvPr id="2" name="TextBox 1"/>
@@ -6908,6 +7061,7 @@
           <a:lstStyle/>
           <a:p>
             <a:pPr algn="ctr"/>
+            <a:endParaRPr/>
           </a:p>
         </p:txBody>
       </p:sp>
@@ -6951,6 +7105,7 @@
           <a:lstStyle/>
           <a:p>
             <a:pPr algn="ctr"/>
+            <a:endParaRPr/>
           </a:p>
         </p:txBody>
       </p:sp>
@@ -6993,7 +7148,7 @@
               </a:spcBef>
             </a:pPr>
             <a:r>
-              <a:rPr b="1" sz="1150">
+              <a:rPr sz="1150" b="1">
                 <a:solidFill>
                   <a:srgbClr val="10B981"/>
                 </a:solidFill>
@@ -7016,7 +7171,7 @@
               </a:spcBef>
             </a:pPr>
             <a:r>
-              <a:rPr b="1" sz="1150">
+              <a:rPr sz="1150" b="1">
                 <a:solidFill>
                   <a:srgbClr val="10B981"/>
                 </a:solidFill>
@@ -7039,7 +7194,7 @@
               </a:spcBef>
             </a:pPr>
             <a:r>
-              <a:rPr b="1" sz="1150">
+              <a:rPr sz="1150" b="1">
                 <a:solidFill>
                   <a:srgbClr val="10B981"/>
                 </a:solidFill>
@@ -7062,7 +7217,7 @@
               </a:spcBef>
             </a:pPr>
             <a:r>
-              <a:rPr b="1" sz="1150">
+              <a:rPr sz="1150" b="1">
                 <a:solidFill>
                   <a:srgbClr val="10B981"/>
                 </a:solidFill>
@@ -7085,7 +7240,7 @@
               </a:spcBef>
             </a:pPr>
             <a:r>
-              <a:rPr b="1" sz="1150">
+              <a:rPr sz="1150" b="1">
                 <a:solidFill>
                   <a:srgbClr val="10B981"/>
                 </a:solidFill>
@@ -7145,6 +7300,7 @@
           <a:lstStyle/>
           <a:p>
             <a:pPr algn="ctr"/>
+            <a:endParaRPr/>
           </a:p>
         </p:txBody>
       </p:sp>
@@ -7188,6 +7344,7 @@
           <a:lstStyle/>
           <a:p>
             <a:pPr algn="ctr"/>
+            <a:endParaRPr/>
           </a:p>
         </p:txBody>
       </p:sp>
@@ -7230,7 +7387,7 @@
               </a:spcBef>
             </a:pPr>
             <a:r>
-              <a:rPr b="1" sz="1150">
+              <a:rPr sz="1150" b="1">
                 <a:solidFill>
                   <a:srgbClr val="EF4444"/>
                 </a:solidFill>
@@ -7253,7 +7410,7 @@
               </a:spcBef>
             </a:pPr>
             <a:r>
-              <a:rPr b="1" sz="1150">
+              <a:rPr sz="1150" b="1">
                 <a:solidFill>
                   <a:srgbClr val="EF4444"/>
                 </a:solidFill>
@@ -7276,7 +7433,7 @@
               </a:spcBef>
             </a:pPr>
             <a:r>
-              <a:rPr b="1" sz="1150">
+              <a:rPr sz="1150" b="1">
                 <a:solidFill>
                   <a:srgbClr val="EF4444"/>
                 </a:solidFill>
@@ -7299,7 +7456,7 @@
               </a:spcBef>
             </a:pPr>
             <a:r>
-              <a:rPr b="1" sz="1150">
+              <a:rPr sz="1150" b="1">
                 <a:solidFill>
                   <a:srgbClr val="EF4444"/>
                 </a:solidFill>

</xml_diff>

<commit_message>
docs: regenerate presentation slides and update README with quick matching features
</commit_message>
<xml_diff>
--- a/ONEDROP_Presentation.pptx
+++ b/ONEDROP_Presentation.pptx
@@ -5,16 +5,16 @@
     <p:sldMasterId id="2147483648" r:id="rId1"/>
   </p:sldMasterIdLst>
   <p:sldIdLst>
-    <p:sldId id="256" r:id="rId2"/>
-    <p:sldId id="257" r:id="rId3"/>
-    <p:sldId id="258" r:id="rId4"/>
-    <p:sldId id="259" r:id="rId5"/>
-    <p:sldId id="260" r:id="rId6"/>
-    <p:sldId id="261" r:id="rId7"/>
-    <p:sldId id="262" r:id="rId8"/>
-    <p:sldId id="263" r:id="rId9"/>
+    <p:sldId id="256" r:id="rId7"/>
+    <p:sldId id="257" r:id="rId8"/>
+    <p:sldId id="258" r:id="rId9"/>
+    <p:sldId id="259" r:id="rId10"/>
+    <p:sldId id="260" r:id="rId11"/>
+    <p:sldId id="261" r:id="rId12"/>
+    <p:sldId id="262" r:id="rId13"/>
+    <p:sldId id="263" r:id="rId14"/>
   </p:sldIdLst>
-  <p:sldSz cx="12192000" cy="6858000"/>
+  <p:sldSz cx="12191695" cy="6858000" type="screen4x3"/>
   <p:notesSz cx="6858000" cy="9144000"/>
   <p:defaultTextStyle>
     <a:defPPr>
@@ -111,75 +111,7 @@
       </a:defRPr>
     </a:lvl9pPr>
   </p:defaultTextStyle>
-  <p:extLst>
-    <p:ext uri="{EFAFB233-063F-42B5-8137-9DF3F51BA10A}">
-      <p15:sldGuideLst xmlns:p15="http://schemas.microsoft.com/office/powerpoint/2012/main">
-        <p15:guide id="1" orient="horz" pos="2160">
-          <p15:clr>
-            <a:srgbClr val="A4A3A4"/>
-          </p15:clr>
-        </p15:guide>
-        <p15:guide id="2" pos="2880">
-          <p15:clr>
-            <a:srgbClr val="A4A3A4"/>
-          </p15:clr>
-        </p15:guide>
-      </p15:sldGuideLst>
-    </p:ext>
-  </p:extLst>
 </p:presentation>
-</file>
-
-<file path=ppt/revisionInfo.xml><?xml version="1.0" encoding="utf-8"?>
-<p1510:revInfo xmlns:a="http://schemas.openxmlformats.org/drawingml/2006/main" xmlns:r="http://schemas.openxmlformats.org/officeDocument/2006/relationships" xmlns:p1510="http://schemas.microsoft.com/office/powerpoint/2015/10/main">
-  <p1510:revLst>
-    <p1510:client id="{5AB72830-43FB-46D1-A7AB-6E8A3445D731}" v="1" dt="2026-06-05T18:46:41.619"/>
-  </p1510:revLst>
-</p1510:revInfo>
-</file>
-
-<file path=ppt/changesInfos/changesInfo1.xml><?xml version="1.0" encoding="utf-8"?>
-<pc:chgInfo xmlns:a="http://schemas.openxmlformats.org/drawingml/2006/main" xmlns:r="http://schemas.openxmlformats.org/officeDocument/2006/relationships" xmlns:ac="http://schemas.microsoft.com/office/drawing/2013/main/command" xmlns:pc="http://schemas.microsoft.com/office/powerpoint/2013/main/command">
-  <pc:docChgLst>
-    <pc:chgData name="Jagadeeswar Reddy" userId="bcd27d93f730bbc2" providerId="LiveId" clId="{126207CD-AAF5-497F-8790-0982E5FEAF21}"/>
-    <pc:docChg chg="modSld">
-      <pc:chgData name="Jagadeeswar Reddy" userId="bcd27d93f730bbc2" providerId="LiveId" clId="{126207CD-AAF5-497F-8790-0982E5FEAF21}" dt="2026-06-05T18:46:41.619" v="0"/>
-      <pc:docMkLst>
-        <pc:docMk/>
-      </pc:docMkLst>
-      <pc:sldChg chg="modSp">
-        <pc:chgData name="Jagadeeswar Reddy" userId="bcd27d93f730bbc2" providerId="LiveId" clId="{126207CD-AAF5-497F-8790-0982E5FEAF21}" dt="2026-06-05T18:46:41.619" v="0"/>
-        <pc:sldMkLst>
-          <pc:docMk/>
-          <pc:sldMk cId="0" sldId="256"/>
-        </pc:sldMkLst>
-        <pc:spChg chg="mod">
-          <ac:chgData name="Jagadeeswar Reddy" userId="bcd27d93f730bbc2" providerId="LiveId" clId="{126207CD-AAF5-497F-8790-0982E5FEAF21}" dt="2026-06-05T18:46:41.619" v="0"/>
-          <ac:spMkLst>
-            <pc:docMk/>
-            <pc:sldMk cId="0" sldId="256"/>
-            <ac:spMk id="3" creationId="{00000000-0000-0000-0000-000000000000}"/>
-          </ac:spMkLst>
-        </pc:spChg>
-      </pc:sldChg>
-      <pc:sldChg chg="modSp">
-        <pc:chgData name="Jagadeeswar Reddy" userId="bcd27d93f730bbc2" providerId="LiveId" clId="{126207CD-AAF5-497F-8790-0982E5FEAF21}" dt="2026-06-05T18:46:41.619" v="0"/>
-        <pc:sldMkLst>
-          <pc:docMk/>
-          <pc:sldMk cId="0" sldId="258"/>
-        </pc:sldMkLst>
-        <pc:spChg chg="mod">
-          <ac:chgData name="Jagadeeswar Reddy" userId="bcd27d93f730bbc2" providerId="LiveId" clId="{126207CD-AAF5-497F-8790-0982E5FEAF21}" dt="2026-06-05T18:46:41.619" v="0"/>
-          <ac:spMkLst>
-            <pc:docMk/>
-            <pc:sldMk cId="0" sldId="258"/>
-            <ac:spMk id="3" creationId="{00000000-0000-0000-0000-000000000000}"/>
-          </ac:spMkLst>
-        </pc:spChg>
-      </pc:sldChg>
-    </pc:docChg>
-  </pc:docChgLst>
-</pc:chgInfo>
 </file>
 
 <file path=ppt/slideLayouts/slideLayout1.xml><?xml version="1.0" encoding="utf-8"?>
@@ -220,9 +152,10 @@
           <a:lstStyle/>
           <a:p>
             <a:r>
-              <a:rPr lang="en-US"/>
+              <a:rPr lang="en-US" smtClean="0"/>
               <a:t>Click to edit Master title style</a:t>
             </a:r>
+            <a:endParaRPr lang="en-US"/>
           </a:p>
         </p:txBody>
       </p:sp>
@@ -338,9 +271,10 @@
           </a:lstStyle>
           <a:p>
             <a:r>
-              <a:rPr lang="en-US"/>
+              <a:rPr lang="en-US" smtClean="0"/>
               <a:t>Click to edit Master subtitle style</a:t>
             </a:r>
+            <a:endParaRPr lang="en-US"/>
           </a:p>
         </p:txBody>
       </p:sp>
@@ -361,7 +295,7 @@
           <a:p>
             <a:fld id="{5BCAD085-E8A6-8845-BD4E-CB4CCA059FC4}" type="datetimeFigureOut">
               <a:rPr lang="en-US" smtClean="0"/>
-              <a:t>6/6/2026</a:t>
+              <a:t>1/27/13</a:t>
             </a:fld>
             <a:endParaRPr lang="en-US"/>
           </a:p>
@@ -455,9 +389,10 @@
           <a:lstStyle/>
           <a:p>
             <a:r>
-              <a:rPr lang="en-US"/>
+              <a:rPr lang="en-US" smtClean="0"/>
               <a:t>Click to edit Master title style</a:t>
             </a:r>
+            <a:endParaRPr lang="en-US"/>
           </a:p>
         </p:txBody>
       </p:sp>
@@ -478,37 +413,38 @@
           <a:p>
             <a:pPr lvl="0"/>
             <a:r>
-              <a:rPr lang="en-US"/>
+              <a:rPr lang="en-US" smtClean="0"/>
               <a:t>Click to edit Master text styles</a:t>
             </a:r>
           </a:p>
           <a:p>
             <a:pPr lvl="1"/>
             <a:r>
-              <a:rPr lang="en-US"/>
+              <a:rPr lang="en-US" smtClean="0"/>
               <a:t>Second level</a:t>
             </a:r>
           </a:p>
           <a:p>
             <a:pPr lvl="2"/>
             <a:r>
-              <a:rPr lang="en-US"/>
+              <a:rPr lang="en-US" smtClean="0"/>
               <a:t>Third level</a:t>
             </a:r>
           </a:p>
           <a:p>
             <a:pPr lvl="3"/>
             <a:r>
-              <a:rPr lang="en-US"/>
+              <a:rPr lang="en-US" smtClean="0"/>
               <a:t>Fourth level</a:t>
             </a:r>
           </a:p>
           <a:p>
             <a:pPr lvl="4"/>
             <a:r>
-              <a:rPr lang="en-US"/>
+              <a:rPr lang="en-US" smtClean="0"/>
               <a:t>Fifth level</a:t>
             </a:r>
+            <a:endParaRPr lang="en-US"/>
           </a:p>
         </p:txBody>
       </p:sp>
@@ -529,7 +465,7 @@
           <a:p>
             <a:fld id="{5BCAD085-E8A6-8845-BD4E-CB4CCA059FC4}" type="datetimeFigureOut">
               <a:rPr lang="en-US" smtClean="0"/>
-              <a:t>6/6/2026</a:t>
+              <a:t>1/27/13</a:t>
             </a:fld>
             <a:endParaRPr lang="en-US"/>
           </a:p>
@@ -628,9 +564,10 @@
           <a:lstStyle/>
           <a:p>
             <a:r>
-              <a:rPr lang="en-US"/>
+              <a:rPr lang="en-US" smtClean="0"/>
               <a:t>Click to edit Master title style</a:t>
             </a:r>
+            <a:endParaRPr lang="en-US"/>
           </a:p>
         </p:txBody>
       </p:sp>
@@ -656,37 +593,38 @@
           <a:p>
             <a:pPr lvl="0"/>
             <a:r>
-              <a:rPr lang="en-US"/>
+              <a:rPr lang="en-US" smtClean="0"/>
               <a:t>Click to edit Master text styles</a:t>
             </a:r>
           </a:p>
           <a:p>
             <a:pPr lvl="1"/>
             <a:r>
-              <a:rPr lang="en-US"/>
+              <a:rPr lang="en-US" smtClean="0"/>
               <a:t>Second level</a:t>
             </a:r>
           </a:p>
           <a:p>
             <a:pPr lvl="2"/>
             <a:r>
-              <a:rPr lang="en-US"/>
+              <a:rPr lang="en-US" smtClean="0"/>
               <a:t>Third level</a:t>
             </a:r>
           </a:p>
           <a:p>
             <a:pPr lvl="3"/>
             <a:r>
-              <a:rPr lang="en-US"/>
+              <a:rPr lang="en-US" smtClean="0"/>
               <a:t>Fourth level</a:t>
             </a:r>
           </a:p>
           <a:p>
             <a:pPr lvl="4"/>
             <a:r>
-              <a:rPr lang="en-US"/>
+              <a:rPr lang="en-US" smtClean="0"/>
               <a:t>Fifth level</a:t>
             </a:r>
+            <a:endParaRPr lang="en-US"/>
           </a:p>
         </p:txBody>
       </p:sp>
@@ -707,7 +645,7 @@
           <a:p>
             <a:fld id="{5BCAD085-E8A6-8845-BD4E-CB4CCA059FC4}" type="datetimeFigureOut">
               <a:rPr lang="en-US" smtClean="0"/>
-              <a:t>6/6/2026</a:t>
+              <a:t>1/27/13</a:t>
             </a:fld>
             <a:endParaRPr lang="en-US"/>
           </a:p>
@@ -801,9 +739,10 @@
           <a:lstStyle/>
           <a:p>
             <a:r>
-              <a:rPr lang="en-US"/>
+              <a:rPr lang="en-US" smtClean="0"/>
               <a:t>Click to edit Master title style</a:t>
             </a:r>
+            <a:endParaRPr lang="en-US"/>
           </a:p>
         </p:txBody>
       </p:sp>
@@ -824,37 +763,38 @@
           <a:p>
             <a:pPr lvl="0"/>
             <a:r>
-              <a:rPr lang="en-US"/>
+              <a:rPr lang="en-US" smtClean="0"/>
               <a:t>Click to edit Master text styles</a:t>
             </a:r>
           </a:p>
           <a:p>
             <a:pPr lvl="1"/>
             <a:r>
-              <a:rPr lang="en-US"/>
+              <a:rPr lang="en-US" smtClean="0"/>
               <a:t>Second level</a:t>
             </a:r>
           </a:p>
           <a:p>
             <a:pPr lvl="2"/>
             <a:r>
-              <a:rPr lang="en-US"/>
+              <a:rPr lang="en-US" smtClean="0"/>
               <a:t>Third level</a:t>
             </a:r>
           </a:p>
           <a:p>
             <a:pPr lvl="3"/>
             <a:r>
-              <a:rPr lang="en-US"/>
+              <a:rPr lang="en-US" smtClean="0"/>
               <a:t>Fourth level</a:t>
             </a:r>
           </a:p>
           <a:p>
             <a:pPr lvl="4"/>
             <a:r>
-              <a:rPr lang="en-US"/>
+              <a:rPr lang="en-US" smtClean="0"/>
               <a:t>Fifth level</a:t>
             </a:r>
+            <a:endParaRPr lang="en-US"/>
           </a:p>
         </p:txBody>
       </p:sp>
@@ -875,7 +815,7 @@
           <a:p>
             <a:fld id="{5BCAD085-E8A6-8845-BD4E-CB4CCA059FC4}" type="datetimeFigureOut">
               <a:rPr lang="en-US" smtClean="0"/>
-              <a:t>6/6/2026</a:t>
+              <a:t>1/27/13</a:t>
             </a:fld>
             <a:endParaRPr lang="en-US"/>
           </a:p>
@@ -978,9 +918,10 @@
           </a:lstStyle>
           <a:p>
             <a:r>
-              <a:rPr lang="en-US"/>
+              <a:rPr lang="en-US" smtClean="0"/>
               <a:t>Click to edit Master title style</a:t>
             </a:r>
+            <a:endParaRPr lang="en-US"/>
           </a:p>
         </p:txBody>
       </p:sp>
@@ -1097,7 +1038,7 @@
           <a:p>
             <a:pPr lvl="0"/>
             <a:r>
-              <a:rPr lang="en-US"/>
+              <a:rPr lang="en-US" smtClean="0"/>
               <a:t>Click to edit Master text styles</a:t>
             </a:r>
           </a:p>
@@ -1120,7 +1061,7 @@
           <a:p>
             <a:fld id="{5BCAD085-E8A6-8845-BD4E-CB4CCA059FC4}" type="datetimeFigureOut">
               <a:rPr lang="en-US" smtClean="0"/>
-              <a:t>6/6/2026</a:t>
+              <a:t>1/27/13</a:t>
             </a:fld>
             <a:endParaRPr lang="en-US"/>
           </a:p>
@@ -1214,9 +1155,10 @@
           <a:lstStyle/>
           <a:p>
             <a:r>
-              <a:rPr lang="en-US"/>
+              <a:rPr lang="en-US" smtClean="0"/>
               <a:t>Click to edit Master title style</a:t>
             </a:r>
+            <a:endParaRPr lang="en-US"/>
           </a:p>
         </p:txBody>
       </p:sp>
@@ -1270,37 +1212,38 @@
           <a:p>
             <a:pPr lvl="0"/>
             <a:r>
-              <a:rPr lang="en-US"/>
+              <a:rPr lang="en-US" smtClean="0"/>
               <a:t>Click to edit Master text styles</a:t>
             </a:r>
           </a:p>
           <a:p>
             <a:pPr lvl="1"/>
             <a:r>
-              <a:rPr lang="en-US"/>
+              <a:rPr lang="en-US" smtClean="0"/>
               <a:t>Second level</a:t>
             </a:r>
           </a:p>
           <a:p>
             <a:pPr lvl="2"/>
             <a:r>
-              <a:rPr lang="en-US"/>
+              <a:rPr lang="en-US" smtClean="0"/>
               <a:t>Third level</a:t>
             </a:r>
           </a:p>
           <a:p>
             <a:pPr lvl="3"/>
             <a:r>
-              <a:rPr lang="en-US"/>
+              <a:rPr lang="en-US" smtClean="0"/>
               <a:t>Fourth level</a:t>
             </a:r>
           </a:p>
           <a:p>
             <a:pPr lvl="4"/>
             <a:r>
-              <a:rPr lang="en-US"/>
+              <a:rPr lang="en-US" smtClean="0"/>
               <a:t>Fifth level</a:t>
             </a:r>
+            <a:endParaRPr lang="en-US"/>
           </a:p>
         </p:txBody>
       </p:sp>
@@ -1354,37 +1297,38 @@
           <a:p>
             <a:pPr lvl="0"/>
             <a:r>
-              <a:rPr lang="en-US"/>
+              <a:rPr lang="en-US" smtClean="0"/>
               <a:t>Click to edit Master text styles</a:t>
             </a:r>
           </a:p>
           <a:p>
             <a:pPr lvl="1"/>
             <a:r>
-              <a:rPr lang="en-US"/>
+              <a:rPr lang="en-US" smtClean="0"/>
               <a:t>Second level</a:t>
             </a:r>
           </a:p>
           <a:p>
             <a:pPr lvl="2"/>
             <a:r>
-              <a:rPr lang="en-US"/>
+              <a:rPr lang="en-US" smtClean="0"/>
               <a:t>Third level</a:t>
             </a:r>
           </a:p>
           <a:p>
             <a:pPr lvl="3"/>
             <a:r>
-              <a:rPr lang="en-US"/>
+              <a:rPr lang="en-US" smtClean="0"/>
               <a:t>Fourth level</a:t>
             </a:r>
           </a:p>
           <a:p>
             <a:pPr lvl="4"/>
             <a:r>
-              <a:rPr lang="en-US"/>
+              <a:rPr lang="en-US" smtClean="0"/>
               <a:t>Fifth level</a:t>
             </a:r>
+            <a:endParaRPr lang="en-US"/>
           </a:p>
         </p:txBody>
       </p:sp>
@@ -1405,7 +1349,7 @@
           <a:p>
             <a:fld id="{5BCAD085-E8A6-8845-BD4E-CB4CCA059FC4}" type="datetimeFigureOut">
               <a:rPr lang="en-US" smtClean="0"/>
-              <a:t>6/6/2026</a:t>
+              <a:t>1/27/13</a:t>
             </a:fld>
             <a:endParaRPr lang="en-US"/>
           </a:p>
@@ -1503,9 +1447,10 @@
           </a:lstStyle>
           <a:p>
             <a:r>
-              <a:rPr lang="en-US"/>
+              <a:rPr lang="en-US" smtClean="0"/>
               <a:t>Click to edit Master title style</a:t>
             </a:r>
+            <a:endParaRPr lang="en-US"/>
           </a:p>
         </p:txBody>
       </p:sp>
@@ -1568,7 +1513,7 @@
           <a:p>
             <a:pPr lvl="0"/>
             <a:r>
-              <a:rPr lang="en-US"/>
+              <a:rPr lang="en-US" smtClean="0"/>
               <a:t>Click to edit Master text styles</a:t>
             </a:r>
           </a:p>
@@ -1624,37 +1569,38 @@
           <a:p>
             <a:pPr lvl="0"/>
             <a:r>
-              <a:rPr lang="en-US"/>
+              <a:rPr lang="en-US" smtClean="0"/>
               <a:t>Click to edit Master text styles</a:t>
             </a:r>
           </a:p>
           <a:p>
             <a:pPr lvl="1"/>
             <a:r>
-              <a:rPr lang="en-US"/>
+              <a:rPr lang="en-US" smtClean="0"/>
               <a:t>Second level</a:t>
             </a:r>
           </a:p>
           <a:p>
             <a:pPr lvl="2"/>
             <a:r>
-              <a:rPr lang="en-US"/>
+              <a:rPr lang="en-US" smtClean="0"/>
               <a:t>Third level</a:t>
             </a:r>
           </a:p>
           <a:p>
             <a:pPr lvl="3"/>
             <a:r>
-              <a:rPr lang="en-US"/>
+              <a:rPr lang="en-US" smtClean="0"/>
               <a:t>Fourth level</a:t>
             </a:r>
           </a:p>
           <a:p>
             <a:pPr lvl="4"/>
             <a:r>
-              <a:rPr lang="en-US"/>
+              <a:rPr lang="en-US" smtClean="0"/>
               <a:t>Fifth level</a:t>
             </a:r>
+            <a:endParaRPr lang="en-US"/>
           </a:p>
         </p:txBody>
       </p:sp>
@@ -1717,7 +1663,7 @@
           <a:p>
             <a:pPr lvl="0"/>
             <a:r>
-              <a:rPr lang="en-US"/>
+              <a:rPr lang="en-US" smtClean="0"/>
               <a:t>Click to edit Master text styles</a:t>
             </a:r>
           </a:p>
@@ -1773,37 +1719,38 @@
           <a:p>
             <a:pPr lvl="0"/>
             <a:r>
-              <a:rPr lang="en-US"/>
+              <a:rPr lang="en-US" smtClean="0"/>
               <a:t>Click to edit Master text styles</a:t>
             </a:r>
           </a:p>
           <a:p>
             <a:pPr lvl="1"/>
             <a:r>
-              <a:rPr lang="en-US"/>
+              <a:rPr lang="en-US" smtClean="0"/>
               <a:t>Second level</a:t>
             </a:r>
           </a:p>
           <a:p>
             <a:pPr lvl="2"/>
             <a:r>
-              <a:rPr lang="en-US"/>
+              <a:rPr lang="en-US" smtClean="0"/>
               <a:t>Third level</a:t>
             </a:r>
           </a:p>
           <a:p>
             <a:pPr lvl="3"/>
             <a:r>
-              <a:rPr lang="en-US"/>
+              <a:rPr lang="en-US" smtClean="0"/>
               <a:t>Fourth level</a:t>
             </a:r>
           </a:p>
           <a:p>
             <a:pPr lvl="4"/>
             <a:r>
-              <a:rPr lang="en-US"/>
+              <a:rPr lang="en-US" smtClean="0"/>
               <a:t>Fifth level</a:t>
             </a:r>
+            <a:endParaRPr lang="en-US"/>
           </a:p>
         </p:txBody>
       </p:sp>
@@ -1824,7 +1771,7 @@
           <a:p>
             <a:fld id="{5BCAD085-E8A6-8845-BD4E-CB4CCA059FC4}" type="datetimeFigureOut">
               <a:rPr lang="en-US" smtClean="0"/>
-              <a:t>6/6/2026</a:t>
+              <a:t>1/27/13</a:t>
             </a:fld>
             <a:endParaRPr lang="en-US"/>
           </a:p>
@@ -1918,9 +1865,10 @@
           <a:lstStyle/>
           <a:p>
             <a:r>
-              <a:rPr lang="en-US"/>
+              <a:rPr lang="en-US" smtClean="0"/>
               <a:t>Click to edit Master title style</a:t>
             </a:r>
+            <a:endParaRPr lang="en-US"/>
           </a:p>
         </p:txBody>
       </p:sp>
@@ -1941,7 +1889,7 @@
           <a:p>
             <a:fld id="{5BCAD085-E8A6-8845-BD4E-CB4CCA059FC4}" type="datetimeFigureOut">
               <a:rPr lang="en-US" smtClean="0"/>
-              <a:t>6/6/2026</a:t>
+              <a:t>1/27/13</a:t>
             </a:fld>
             <a:endParaRPr lang="en-US"/>
           </a:p>
@@ -2036,7 +1984,7 @@
           <a:p>
             <a:fld id="{5BCAD085-E8A6-8845-BD4E-CB4CCA059FC4}" type="datetimeFigureOut">
               <a:rPr lang="en-US" smtClean="0"/>
-              <a:t>6/6/2026</a:t>
+              <a:t>1/27/13</a:t>
             </a:fld>
             <a:endParaRPr lang="en-US"/>
           </a:p>
@@ -2139,9 +2087,10 @@
           </a:lstStyle>
           <a:p>
             <a:r>
-              <a:rPr lang="en-US"/>
+              <a:rPr lang="en-US" smtClean="0"/>
               <a:t>Click to edit Master title style</a:t>
             </a:r>
+            <a:endParaRPr lang="en-US"/>
           </a:p>
         </p:txBody>
       </p:sp>
@@ -2195,37 +2144,38 @@
           <a:p>
             <a:pPr lvl="0"/>
             <a:r>
-              <a:rPr lang="en-US"/>
+              <a:rPr lang="en-US" smtClean="0"/>
               <a:t>Click to edit Master text styles</a:t>
             </a:r>
           </a:p>
           <a:p>
             <a:pPr lvl="1"/>
             <a:r>
-              <a:rPr lang="en-US"/>
+              <a:rPr lang="en-US" smtClean="0"/>
               <a:t>Second level</a:t>
             </a:r>
           </a:p>
           <a:p>
             <a:pPr lvl="2"/>
             <a:r>
-              <a:rPr lang="en-US"/>
+              <a:rPr lang="en-US" smtClean="0"/>
               <a:t>Third level</a:t>
             </a:r>
           </a:p>
           <a:p>
             <a:pPr lvl="3"/>
             <a:r>
-              <a:rPr lang="en-US"/>
+              <a:rPr lang="en-US" smtClean="0"/>
               <a:t>Fourth level</a:t>
             </a:r>
           </a:p>
           <a:p>
             <a:pPr lvl="4"/>
             <a:r>
-              <a:rPr lang="en-US"/>
+              <a:rPr lang="en-US" smtClean="0"/>
               <a:t>Fifth level</a:t>
             </a:r>
+            <a:endParaRPr lang="en-US"/>
           </a:p>
         </p:txBody>
       </p:sp>
@@ -2288,7 +2238,7 @@
           <a:p>
             <a:pPr lvl="0"/>
             <a:r>
-              <a:rPr lang="en-US"/>
+              <a:rPr lang="en-US" smtClean="0"/>
               <a:t>Click to edit Master text styles</a:t>
             </a:r>
           </a:p>
@@ -2311,7 +2261,7 @@
           <a:p>
             <a:fld id="{5BCAD085-E8A6-8845-BD4E-CB4CCA059FC4}" type="datetimeFigureOut">
               <a:rPr lang="en-US" smtClean="0"/>
-              <a:t>6/6/2026</a:t>
+              <a:t>1/27/13</a:t>
             </a:fld>
             <a:endParaRPr lang="en-US"/>
           </a:p>
@@ -2414,9 +2364,10 @@
           </a:lstStyle>
           <a:p>
             <a:r>
-              <a:rPr lang="en-US"/>
+              <a:rPr lang="en-US" smtClean="0"/>
               <a:t>Click to edit Master title style</a:t>
             </a:r>
+            <a:endParaRPr lang="en-US"/>
           </a:p>
         </p:txBody>
       </p:sp>
@@ -2540,7 +2491,7 @@
           <a:p>
             <a:pPr lvl="0"/>
             <a:r>
-              <a:rPr lang="en-US"/>
+              <a:rPr lang="en-US" smtClean="0"/>
               <a:t>Click to edit Master text styles</a:t>
             </a:r>
           </a:p>
@@ -2563,7 +2514,7 @@
           <a:p>
             <a:fld id="{5BCAD085-E8A6-8845-BD4E-CB4CCA059FC4}" type="datetimeFigureOut">
               <a:rPr lang="en-US" smtClean="0"/>
-              <a:t>6/6/2026</a:t>
+              <a:t>1/27/13</a:t>
             </a:fld>
             <a:endParaRPr lang="en-US"/>
           </a:p>
@@ -2672,9 +2623,10 @@
           <a:lstStyle/>
           <a:p>
             <a:r>
-              <a:rPr lang="en-US"/>
+              <a:rPr lang="en-US" smtClean="0"/>
               <a:t>Click to edit Master title style</a:t>
             </a:r>
+            <a:endParaRPr lang="en-US"/>
           </a:p>
         </p:txBody>
       </p:sp>
@@ -2705,37 +2657,38 @@
           <a:p>
             <a:pPr lvl="0"/>
             <a:r>
-              <a:rPr lang="en-US"/>
+              <a:rPr lang="en-US" smtClean="0"/>
               <a:t>Click to edit Master text styles</a:t>
             </a:r>
           </a:p>
           <a:p>
             <a:pPr lvl="1"/>
             <a:r>
-              <a:rPr lang="en-US"/>
+              <a:rPr lang="en-US" smtClean="0"/>
               <a:t>Second level</a:t>
             </a:r>
           </a:p>
           <a:p>
             <a:pPr lvl="2"/>
             <a:r>
-              <a:rPr lang="en-US"/>
+              <a:rPr lang="en-US" smtClean="0"/>
               <a:t>Third level</a:t>
             </a:r>
           </a:p>
           <a:p>
             <a:pPr lvl="3"/>
             <a:r>
-              <a:rPr lang="en-US"/>
+              <a:rPr lang="en-US" smtClean="0"/>
               <a:t>Fourth level</a:t>
             </a:r>
           </a:p>
           <a:p>
             <a:pPr lvl="4"/>
             <a:r>
-              <a:rPr lang="en-US"/>
+              <a:rPr lang="en-US" smtClean="0"/>
               <a:t>Fifth level</a:t>
             </a:r>
+            <a:endParaRPr lang="en-US"/>
           </a:p>
         </p:txBody>
       </p:sp>
@@ -2774,7 +2727,7 @@
           <a:p>
             <a:fld id="{5BCAD085-E8A6-8845-BD4E-CB4CCA059FC4}" type="datetimeFigureOut">
               <a:rPr lang="en-US" smtClean="0"/>
-              <a:t>6/6/2026</a:t>
+              <a:t>1/27/13</a:t>
             </a:fld>
             <a:endParaRPr lang="en-US"/>
           </a:p>
@@ -3133,7 +3086,7 @@
 </file>
 
 <file path=ppt/slides/slide1.xml><?xml version="1.0" encoding="utf-8"?>
-<p:sld xmlns:a="http://schemas.openxmlformats.org/drawingml/2006/main" xmlns:r="http://schemas.openxmlformats.org/officeDocument/2006/relationships" xmlns:p="http://schemas.openxmlformats.org/presentationml/2006/main">
+<p:sld xmlns:a="http://schemas.openxmlformats.org/drawingml/2006/main" xmlns:p="http://schemas.openxmlformats.org/presentationml/2006/main" xmlns:r="http://schemas.openxmlformats.org/officeDocument/2006/relationships">
   <p:cSld>
     <p:bg>
       <p:bgPr>
@@ -3149,14 +3102,7 @@
         <p:cNvGrpSpPr/>
         <p:nvPr/>
       </p:nvGrpSpPr>
-      <p:grpSpPr>
-        <a:xfrm>
-          <a:off x="0" y="0"/>
-          <a:ext cx="0" cy="0"/>
-          <a:chOff x="0" y="0"/>
-          <a:chExt cx="0" cy="0"/>
-        </a:xfrm>
-      </p:grpSpPr>
+      <p:grpSpPr/>
       <p:sp>
         <p:nvSpPr>
           <p:cNvPr id="2" name="Rectangle 1"/>
@@ -3197,7 +3143,6 @@
           <a:lstStyle/>
           <a:p>
             <a:pPr algn="ctr"/>
-            <a:endParaRPr/>
           </a:p>
         </p:txBody>
       </p:sp>
@@ -3210,7 +3155,7 @@
         <p:spPr>
           <a:xfrm>
             <a:off x="1097280" y="2011680"/>
-            <a:ext cx="10058400" cy="2185214"/>
+            <a:ext cx="10058400" cy="3657600"/>
           </a:xfrm>
           <a:prstGeom prst="rect">
             <a:avLst/>
@@ -3224,20 +3169,14 @@
           <a:lstStyle/>
           <a:p>
             <a:r>
-              <a:rPr lang="en-GB" sz="6400" b="1" dirty="0" err="1">
+              <a:rPr sz="6400" b="1">
                 <a:solidFill>
                   <a:srgbClr val="FFFFFF"/>
                 </a:solidFill>
                 <a:latin typeface="Arial"/>
               </a:rPr>
-              <a:t>onedrop</a:t>
-            </a:r>
-            <a:endParaRPr sz="6400" b="1" dirty="0">
-              <a:solidFill>
-                <a:srgbClr val="FFFFFF"/>
-              </a:solidFill>
-              <a:latin typeface="Arial"/>
-            </a:endParaRPr>
+              <a:t>ONEDROP</a:t>
+            </a:r>
           </a:p>
           <a:p>
             <a:pPr>
@@ -3246,7 +3185,7 @@
               </a:spcBef>
             </a:pPr>
             <a:r>
-              <a:rPr sz="2000" b="1" dirty="0">
+              <a:rPr sz="2000" b="1">
                 <a:solidFill>
                   <a:srgbClr val="EF4444"/>
                 </a:solidFill>
@@ -3262,7 +3201,7 @@
               </a:spcBef>
             </a:pPr>
             <a:r>
-              <a:rPr sz="1400" dirty="0">
+              <a:rPr sz="1400">
                 <a:solidFill>
                   <a:srgbClr val="94A3B8"/>
                 </a:solidFill>
@@ -3316,7 +3255,7 @@
 </file>
 
 <file path=ppt/slides/slide2.xml><?xml version="1.0" encoding="utf-8"?>
-<p:sld xmlns:a="http://schemas.openxmlformats.org/drawingml/2006/main" xmlns:r="http://schemas.openxmlformats.org/officeDocument/2006/relationships" xmlns:p="http://schemas.openxmlformats.org/presentationml/2006/main">
+<p:sld xmlns:a="http://schemas.openxmlformats.org/drawingml/2006/main" xmlns:p="http://schemas.openxmlformats.org/presentationml/2006/main" xmlns:r="http://schemas.openxmlformats.org/officeDocument/2006/relationships">
   <p:cSld>
     <p:bg>
       <p:bgPr>
@@ -3332,14 +3271,7 @@
         <p:cNvGrpSpPr/>
         <p:nvPr/>
       </p:nvGrpSpPr>
-      <p:grpSpPr>
-        <a:xfrm>
-          <a:off x="0" y="0"/>
-          <a:ext cx="0" cy="0"/>
-          <a:chOff x="0" y="0"/>
-          <a:chExt cx="0" cy="0"/>
-        </a:xfrm>
-      </p:grpSpPr>
+      <p:grpSpPr/>
       <p:sp>
         <p:nvSpPr>
           <p:cNvPr id="2" name="TextBox 1"/>
@@ -3450,7 +3382,6 @@
           <a:lstStyle/>
           <a:p>
             <a:pPr algn="ctr"/>
-            <a:endParaRPr/>
           </a:p>
         </p:txBody>
       </p:sp>
@@ -3494,7 +3425,6 @@
           <a:lstStyle/>
           <a:p>
             <a:pPr algn="ctr"/>
-            <a:endParaRPr/>
           </a:p>
         </p:txBody>
       </p:sp>
@@ -3606,7 +3536,6 @@
           <a:lstStyle/>
           <a:p>
             <a:pPr algn="ctr"/>
-            <a:endParaRPr/>
           </a:p>
         </p:txBody>
       </p:sp>
@@ -3650,7 +3579,6 @@
           <a:lstStyle/>
           <a:p>
             <a:pPr algn="ctr"/>
-            <a:endParaRPr/>
           </a:p>
         </p:txBody>
       </p:sp>
@@ -3762,7 +3690,6 @@
           <a:lstStyle/>
           <a:p>
             <a:pPr algn="ctr"/>
-            <a:endParaRPr/>
           </a:p>
         </p:txBody>
       </p:sp>
@@ -3806,7 +3733,6 @@
           <a:lstStyle/>
           <a:p>
             <a:pPr algn="ctr"/>
-            <a:endParaRPr/>
           </a:p>
         </p:txBody>
       </p:sp>
@@ -3885,7 +3811,7 @@
 </file>
 
 <file path=ppt/slides/slide3.xml><?xml version="1.0" encoding="utf-8"?>
-<p:sld xmlns:a="http://schemas.openxmlformats.org/drawingml/2006/main" xmlns:r="http://schemas.openxmlformats.org/officeDocument/2006/relationships" xmlns:p="http://schemas.openxmlformats.org/presentationml/2006/main">
+<p:sld xmlns:a="http://schemas.openxmlformats.org/drawingml/2006/main" xmlns:p="http://schemas.openxmlformats.org/presentationml/2006/main" xmlns:r="http://schemas.openxmlformats.org/officeDocument/2006/relationships">
   <p:cSld>
     <p:bg>
       <p:bgPr>
@@ -3901,14 +3827,7 @@
         <p:cNvGrpSpPr/>
         <p:nvPr/>
       </p:nvGrpSpPr>
-      <p:grpSpPr>
-        <a:xfrm>
-          <a:off x="0" y="0"/>
-          <a:ext cx="0" cy="0"/>
-          <a:chOff x="0" y="0"/>
-          <a:chExt cx="0" cy="0"/>
-        </a:xfrm>
-      </p:grpSpPr>
+      <p:grpSpPr/>
       <p:sp>
         <p:nvSpPr>
           <p:cNvPr id="2" name="TextBox 1"/>
@@ -3952,7 +3871,7 @@
         <p:spPr>
           <a:xfrm>
             <a:off x="731520" y="594360"/>
-            <a:ext cx="10728655" cy="430887"/>
+            <a:ext cx="10728655" cy="731520"/>
           </a:xfrm>
           <a:prstGeom prst="rect">
             <a:avLst/>
@@ -3966,22 +3885,13 @@
           <a:lstStyle/>
           <a:p>
             <a:r>
-              <a:rPr lang="en-GB" sz="2800" b="1" dirty="0" err="1">
+              <a:rPr sz="2800" b="1">
                 <a:solidFill>
                   <a:srgbClr val="FFFFFF"/>
                 </a:solidFill>
                 <a:latin typeface="Arial"/>
               </a:rPr>
-              <a:t>onedrop</a:t>
-            </a:r>
-            <a:r>
-              <a:rPr sz="2800" b="1" dirty="0">
-                <a:solidFill>
-                  <a:srgbClr val="FFFFFF"/>
-                </a:solidFill>
-                <a:latin typeface="Arial"/>
-              </a:rPr>
-              <a:t>: The Intelligent Blood Bridge</a:t>
+              <a:t>ONEDROP: The Intelligent Blood Bridge</a:t>
             </a:r>
           </a:p>
         </p:txBody>
@@ -4028,7 +3938,6 @@
           <a:lstStyle/>
           <a:p>
             <a:pPr algn="ctr"/>
-            <a:endParaRPr/>
           </a:p>
         </p:txBody>
       </p:sp>
@@ -4072,7 +3981,6 @@
           <a:lstStyle/>
           <a:p>
             <a:pPr algn="ctr"/>
-            <a:endParaRPr/>
           </a:p>
         </p:txBody>
       </p:sp>
@@ -4184,7 +4092,6 @@
           <a:lstStyle/>
           <a:p>
             <a:pPr algn="ctr"/>
-            <a:endParaRPr/>
           </a:p>
         </p:txBody>
       </p:sp>
@@ -4228,7 +4135,6 @@
           <a:lstStyle/>
           <a:p>
             <a:pPr algn="ctr"/>
-            <a:endParaRPr/>
           </a:p>
         </p:txBody>
       </p:sp>
@@ -4340,7 +4246,6 @@
           <a:lstStyle/>
           <a:p>
             <a:pPr algn="ctr"/>
-            <a:endParaRPr/>
           </a:p>
         </p:txBody>
       </p:sp>
@@ -4384,7 +4289,6 @@
           <a:lstStyle/>
           <a:p>
             <a:pPr algn="ctr"/>
-            <a:endParaRPr/>
           </a:p>
         </p:txBody>
       </p:sp>
@@ -4496,7 +4400,6 @@
           <a:lstStyle/>
           <a:p>
             <a:pPr algn="ctr"/>
-            <a:endParaRPr/>
           </a:p>
         </p:txBody>
       </p:sp>
@@ -4540,7 +4443,6 @@
           <a:lstStyle/>
           <a:p>
             <a:pPr algn="ctr"/>
-            <a:endParaRPr/>
           </a:p>
         </p:txBody>
       </p:sp>
@@ -4619,7 +4521,7 @@
 </file>
 
 <file path=ppt/slides/slide4.xml><?xml version="1.0" encoding="utf-8"?>
-<p:sld xmlns:a="http://schemas.openxmlformats.org/drawingml/2006/main" xmlns:r="http://schemas.openxmlformats.org/officeDocument/2006/relationships" xmlns:p="http://schemas.openxmlformats.org/presentationml/2006/main">
+<p:sld xmlns:a="http://schemas.openxmlformats.org/drawingml/2006/main" xmlns:p="http://schemas.openxmlformats.org/presentationml/2006/main" xmlns:r="http://schemas.openxmlformats.org/officeDocument/2006/relationships">
   <p:cSld>
     <p:bg>
       <p:bgPr>
@@ -4635,14 +4537,7 @@
         <p:cNvGrpSpPr/>
         <p:nvPr/>
       </p:nvGrpSpPr>
-      <p:grpSpPr>
-        <a:xfrm>
-          <a:off x="0" y="0"/>
-          <a:ext cx="0" cy="0"/>
-          <a:chOff x="0" y="0"/>
-          <a:chExt cx="0" cy="0"/>
-        </a:xfrm>
-      </p:grpSpPr>
+      <p:grpSpPr/>
       <p:sp>
         <p:nvSpPr>
           <p:cNvPr id="2" name="TextBox 1"/>
@@ -4753,7 +4648,6 @@
           <a:lstStyle/>
           <a:p>
             <a:pPr algn="ctr"/>
-            <a:endParaRPr/>
           </a:p>
         </p:txBody>
       </p:sp>
@@ -4797,7 +4691,6 @@
           <a:lstStyle/>
           <a:p>
             <a:pPr algn="ctr"/>
-            <a:endParaRPr/>
           </a:p>
         </p:txBody>
       </p:sp>
@@ -4902,7 +4795,6 @@
           <a:lstStyle/>
           <a:p>
             <a:pPr algn="ctr"/>
-            <a:endParaRPr/>
           </a:p>
         </p:txBody>
       </p:sp>
@@ -4946,7 +4838,6 @@
           <a:lstStyle/>
           <a:p>
             <a:pPr algn="ctr"/>
-            <a:endParaRPr/>
           </a:p>
         </p:txBody>
       </p:sp>
@@ -5051,7 +4942,6 @@
           <a:lstStyle/>
           <a:p>
             <a:pPr algn="ctr"/>
-            <a:endParaRPr/>
           </a:p>
         </p:txBody>
       </p:sp>
@@ -5095,7 +4985,6 @@
           <a:lstStyle/>
           <a:p>
             <a:pPr algn="ctr"/>
-            <a:endParaRPr/>
           </a:p>
         </p:txBody>
       </p:sp>
@@ -5200,7 +5089,6 @@
           <a:lstStyle/>
           <a:p>
             <a:pPr algn="ctr"/>
-            <a:endParaRPr/>
           </a:p>
         </p:txBody>
       </p:sp>
@@ -5244,7 +5132,6 @@
           <a:lstStyle/>
           <a:p>
             <a:pPr algn="ctr"/>
-            <a:endParaRPr/>
           </a:p>
         </p:txBody>
       </p:sp>
@@ -5316,7 +5203,7 @@
 </file>
 
 <file path=ppt/slides/slide5.xml><?xml version="1.0" encoding="utf-8"?>
-<p:sld xmlns:a="http://schemas.openxmlformats.org/drawingml/2006/main" xmlns:r="http://schemas.openxmlformats.org/officeDocument/2006/relationships" xmlns:p="http://schemas.openxmlformats.org/presentationml/2006/main">
+<p:sld xmlns:a="http://schemas.openxmlformats.org/drawingml/2006/main" xmlns:p="http://schemas.openxmlformats.org/presentationml/2006/main" xmlns:r="http://schemas.openxmlformats.org/officeDocument/2006/relationships">
   <p:cSld>
     <p:bg>
       <p:bgPr>
@@ -5332,14 +5219,7 @@
         <p:cNvGrpSpPr/>
         <p:nvPr/>
       </p:nvGrpSpPr>
-      <p:grpSpPr>
-        <a:xfrm>
-          <a:off x="0" y="0"/>
-          <a:ext cx="0" cy="0"/>
-          <a:chOff x="0" y="0"/>
-          <a:chExt cx="0" cy="0"/>
-        </a:xfrm>
-      </p:grpSpPr>
+      <p:grpSpPr/>
       <p:sp>
         <p:nvSpPr>
           <p:cNvPr id="2" name="TextBox 1"/>
@@ -5450,7 +5330,6 @@
           <a:lstStyle/>
           <a:p>
             <a:pPr algn="ctr"/>
-            <a:endParaRPr/>
           </a:p>
         </p:txBody>
       </p:sp>
@@ -5494,7 +5373,6 @@
           <a:lstStyle/>
           <a:p>
             <a:pPr algn="ctr"/>
-            <a:endParaRPr/>
           </a:p>
         </p:txBody>
       </p:sp>
@@ -5599,7 +5477,7 @@
                 </a:solidFill>
                 <a:latin typeface="Arial"/>
               </a:rPr>
-              <a:t>Comprehensive medical documentation &amp; upload interface.</a:t>
+              <a:t>Quick matching donors modal for published request tickets.</a:t>
             </a:r>
           </a:p>
           <a:p>
@@ -5623,7 +5501,7 @@
                 </a:solidFill>
                 <a:latin typeface="Arial"/>
               </a:rPr>
-              <a:t>Upcoming campaign registrations and historic timeline.</a:t>
+              <a:t>⚡ Contact Fast with Call, Chat, WhatsApp, &amp; custom alerts.</a:t>
             </a:r>
           </a:p>
         </p:txBody>
@@ -5670,7 +5548,6 @@
           <a:lstStyle/>
           <a:p>
             <a:pPr algn="ctr"/>
-            <a:endParaRPr/>
           </a:p>
         </p:txBody>
       </p:sp>
@@ -5714,7 +5591,6 @@
           <a:lstStyle/>
           <a:p>
             <a:pPr algn="ctr"/>
-            <a:endParaRPr/>
           </a:p>
         </p:txBody>
       </p:sp>
@@ -5819,7 +5695,7 @@
                 </a:solidFill>
                 <a:latin typeface="Arial"/>
               </a:rPr>
-              <a:t>Advanced donor directory with proximity filtering.</a:t>
+              <a:t>⚡ Contact Fast: Proximity matching donors modal trigger.</a:t>
             </a:r>
           </a:p>
           <a:p>
@@ -5843,7 +5719,7 @@
                 </a:solidFill>
                 <a:latin typeface="Arial"/>
               </a:rPr>
-              <a:t>Official campaign builder and notification broadcasts.</a:t>
+              <a:t>Build &amp; publish donation campaigns with instant alerts.</a:t>
             </a:r>
           </a:p>
         </p:txBody>
@@ -5890,7 +5766,6 @@
           <a:lstStyle/>
           <a:p>
             <a:pPr algn="ctr"/>
-            <a:endParaRPr/>
           </a:p>
         </p:txBody>
       </p:sp>
@@ -5934,7 +5809,6 @@
           <a:lstStyle/>
           <a:p>
             <a:pPr algn="ctr"/>
-            <a:endParaRPr/>
           </a:p>
         </p:txBody>
       </p:sp>
@@ -5991,7 +5865,7 @@
                 </a:solidFill>
                 <a:latin typeface="Arial"/>
               </a:rPr>
-              <a:t>Fast, clean blood emergency requests generation wizard.</a:t>
+              <a:t>Clean emergency request creation with instant matches popup.</a:t>
             </a:r>
           </a:p>
           <a:p>
@@ -6015,7 +5889,7 @@
                 </a:solidFill>
                 <a:latin typeface="Arial"/>
               </a:rPr>
-              <a:t>P2P direct chat hub for immediate donor coordinate sessions.</a:t>
+              <a:t>⚡ Contact Fast shortcuts (Call, Chat, WhatsApp, Alert).</a:t>
             </a:r>
           </a:p>
           <a:p>
@@ -6039,7 +5913,7 @@
                 </a:solidFill>
                 <a:latin typeface="Arial"/>
               </a:rPr>
-              <a:t>Admin audit logs, campaign moderation, and user checks.</a:t>
+              <a:t>Admin audit logs, campaign moderation, and system checks.</a:t>
             </a:r>
           </a:p>
           <a:p>
@@ -6063,7 +5937,7 @@
                 </a:solidFill>
                 <a:latin typeface="Arial"/>
               </a:rPr>
-              <a:t>Comprehensive visual metrics representing platform status.</a:t>
+              <a:t>Interactive chat workspace with attachment &amp; GPS sharing.</a:t>
             </a:r>
           </a:p>
         </p:txBody>
@@ -6077,7 +5951,7 @@
 </file>
 
 <file path=ppt/slides/slide6.xml><?xml version="1.0" encoding="utf-8"?>
-<p:sld xmlns:a="http://schemas.openxmlformats.org/drawingml/2006/main" xmlns:r="http://schemas.openxmlformats.org/officeDocument/2006/relationships" xmlns:p="http://schemas.openxmlformats.org/presentationml/2006/main">
+<p:sld xmlns:a="http://schemas.openxmlformats.org/drawingml/2006/main" xmlns:p="http://schemas.openxmlformats.org/presentationml/2006/main" xmlns:r="http://schemas.openxmlformats.org/officeDocument/2006/relationships">
   <p:cSld>
     <p:bg>
       <p:bgPr>
@@ -6093,14 +5967,7 @@
         <p:cNvGrpSpPr/>
         <p:nvPr/>
       </p:nvGrpSpPr>
-      <p:grpSpPr>
-        <a:xfrm>
-          <a:off x="0" y="0"/>
-          <a:ext cx="0" cy="0"/>
-          <a:chOff x="0" y="0"/>
-          <a:chExt cx="0" cy="0"/>
-        </a:xfrm>
-      </p:grpSpPr>
+      <p:grpSpPr/>
       <p:sp>
         <p:nvSpPr>
           <p:cNvPr id="2" name="TextBox 1"/>
@@ -6211,7 +6078,6 @@
           <a:lstStyle/>
           <a:p>
             <a:pPr algn="ctr"/>
-            <a:endParaRPr/>
           </a:p>
         </p:txBody>
       </p:sp>
@@ -6255,7 +6121,6 @@
           <a:lstStyle/>
           <a:p>
             <a:pPr algn="ctr"/>
-            <a:endParaRPr/>
           </a:p>
         </p:txBody>
       </p:sp>
@@ -6298,7 +6163,7 @@
               </a:spcBef>
             </a:pPr>
             <a:r>
-              <a:rPr sz="1200" b="1">
+              <a:rPr b="1" sz="1200">
                 <a:solidFill>
                   <a:srgbClr val="EF4444"/>
                 </a:solidFill>
@@ -6321,7 +6186,7 @@
               </a:spcBef>
             </a:pPr>
             <a:r>
-              <a:rPr sz="1200" b="1">
+              <a:rPr b="1" sz="1200">
                 <a:solidFill>
                   <a:srgbClr val="EF4444"/>
                 </a:solidFill>
@@ -6344,7 +6209,7 @@
               </a:spcBef>
             </a:pPr>
             <a:r>
-              <a:rPr sz="1200" b="1">
+              <a:rPr b="1" sz="1200">
                 <a:solidFill>
                   <a:srgbClr val="EF4444"/>
                 </a:solidFill>
@@ -6367,7 +6232,7 @@
               </a:spcBef>
             </a:pPr>
             <a:r>
-              <a:rPr sz="1200" b="1">
+              <a:rPr b="1" sz="1200">
                 <a:solidFill>
                   <a:srgbClr val="EF4444"/>
                 </a:solidFill>
@@ -6427,7 +6292,6 @@
           <a:lstStyle/>
           <a:p>
             <a:pPr algn="ctr"/>
-            <a:endParaRPr/>
           </a:p>
         </p:txBody>
       </p:sp>
@@ -6471,7 +6335,6 @@
           <a:lstStyle/>
           <a:p>
             <a:pPr algn="ctr"/>
-            <a:endParaRPr/>
           </a:p>
         </p:txBody>
       </p:sp>
@@ -6514,7 +6377,7 @@
               </a:spcBef>
             </a:pPr>
             <a:r>
-              <a:rPr sz="1200" b="1">
+              <a:rPr b="1" sz="1200">
                 <a:solidFill>
                   <a:srgbClr val="10B981"/>
                 </a:solidFill>
@@ -6537,7 +6400,7 @@
               </a:spcBef>
             </a:pPr>
             <a:r>
-              <a:rPr sz="1200" b="1">
+              <a:rPr b="1" sz="1200">
                 <a:solidFill>
                   <a:srgbClr val="10B981"/>
                 </a:solidFill>
@@ -6560,7 +6423,7 @@
               </a:spcBef>
             </a:pPr>
             <a:r>
-              <a:rPr sz="1200" b="1">
+              <a:rPr b="1" sz="1200">
                 <a:solidFill>
                   <a:srgbClr val="10B981"/>
                 </a:solidFill>
@@ -6583,7 +6446,7 @@
               </a:spcBef>
             </a:pPr>
             <a:r>
-              <a:rPr sz="1200" b="1">
+              <a:rPr b="1" sz="1200">
                 <a:solidFill>
                   <a:srgbClr val="10B981"/>
                 </a:solidFill>
@@ -6610,7 +6473,7 @@
 </file>
 
 <file path=ppt/slides/slide7.xml><?xml version="1.0" encoding="utf-8"?>
-<p:sld xmlns:a="http://schemas.openxmlformats.org/drawingml/2006/main" xmlns:r="http://schemas.openxmlformats.org/officeDocument/2006/relationships" xmlns:p="http://schemas.openxmlformats.org/presentationml/2006/main">
+<p:sld xmlns:a="http://schemas.openxmlformats.org/drawingml/2006/main" xmlns:p="http://schemas.openxmlformats.org/presentationml/2006/main" xmlns:r="http://schemas.openxmlformats.org/officeDocument/2006/relationships">
   <p:cSld>
     <p:bg>
       <p:bgPr>
@@ -6626,14 +6489,7 @@
         <p:cNvGrpSpPr/>
         <p:nvPr/>
       </p:nvGrpSpPr>
-      <p:grpSpPr>
-        <a:xfrm>
-          <a:off x="0" y="0"/>
-          <a:ext cx="0" cy="0"/>
-          <a:chOff x="0" y="0"/>
-          <a:chExt cx="0" cy="0"/>
-        </a:xfrm>
-      </p:grpSpPr>
+      <p:grpSpPr/>
       <p:sp>
         <p:nvSpPr>
           <p:cNvPr id="2" name="TextBox 1"/>
@@ -6744,7 +6600,6 @@
           <a:lstStyle/>
           <a:p>
             <a:pPr algn="ctr"/>
-            <a:endParaRPr/>
           </a:p>
         </p:txBody>
       </p:sp>
@@ -6788,7 +6643,6 @@
           <a:lstStyle/>
           <a:p>
             <a:pPr algn="ctr"/>
-            <a:endParaRPr/>
           </a:p>
         </p:txBody>
       </p:sp>
@@ -6831,7 +6685,7 @@
               </a:spcBef>
             </a:pPr>
             <a:r>
-              <a:rPr sz="1350" b="1">
+              <a:rPr b="1" sz="1350">
                 <a:solidFill>
                   <a:srgbClr val="F59E0B"/>
                 </a:solidFill>
@@ -6854,7 +6708,7 @@
               </a:spcBef>
             </a:pPr>
             <a:r>
-              <a:rPr sz="1350" b="1">
+              <a:rPr b="1" sz="1350">
                 <a:solidFill>
                   <a:srgbClr val="F59E0B"/>
                 </a:solidFill>
@@ -6877,7 +6731,7 @@
               </a:spcBef>
             </a:pPr>
             <a:r>
-              <a:rPr sz="1350" b="1">
+              <a:rPr b="1" sz="1350">
                 <a:solidFill>
                   <a:srgbClr val="F59E0B"/>
                 </a:solidFill>
@@ -6900,7 +6754,7 @@
               </a:spcBef>
             </a:pPr>
             <a:r>
-              <a:rPr sz="1350" b="1">
+              <a:rPr b="1" sz="1350">
                 <a:solidFill>
                   <a:srgbClr val="F59E0B"/>
                 </a:solidFill>
@@ -6927,7 +6781,7 @@
 </file>
 
 <file path=ppt/slides/slide8.xml><?xml version="1.0" encoding="utf-8"?>
-<p:sld xmlns:a="http://schemas.openxmlformats.org/drawingml/2006/main" xmlns:r="http://schemas.openxmlformats.org/officeDocument/2006/relationships" xmlns:p="http://schemas.openxmlformats.org/presentationml/2006/main">
+<p:sld xmlns:a="http://schemas.openxmlformats.org/drawingml/2006/main" xmlns:p="http://schemas.openxmlformats.org/presentationml/2006/main" xmlns:r="http://schemas.openxmlformats.org/officeDocument/2006/relationships">
   <p:cSld>
     <p:bg>
       <p:bgPr>
@@ -6943,14 +6797,7 @@
         <p:cNvGrpSpPr/>
         <p:nvPr/>
       </p:nvGrpSpPr>
-      <p:grpSpPr>
-        <a:xfrm>
-          <a:off x="0" y="0"/>
-          <a:ext cx="0" cy="0"/>
-          <a:chOff x="0" y="0"/>
-          <a:chExt cx="0" cy="0"/>
-        </a:xfrm>
-      </p:grpSpPr>
+      <p:grpSpPr/>
       <p:sp>
         <p:nvSpPr>
           <p:cNvPr id="2" name="TextBox 1"/>
@@ -7061,7 +6908,6 @@
           <a:lstStyle/>
           <a:p>
             <a:pPr algn="ctr"/>
-            <a:endParaRPr/>
           </a:p>
         </p:txBody>
       </p:sp>
@@ -7105,7 +6951,6 @@
           <a:lstStyle/>
           <a:p>
             <a:pPr algn="ctr"/>
-            <a:endParaRPr/>
           </a:p>
         </p:txBody>
       </p:sp>
@@ -7148,7 +6993,7 @@
               </a:spcBef>
             </a:pPr>
             <a:r>
-              <a:rPr sz="1150" b="1">
+              <a:rPr b="1" sz="1150">
                 <a:solidFill>
                   <a:srgbClr val="10B981"/>
                 </a:solidFill>
@@ -7171,7 +7016,7 @@
               </a:spcBef>
             </a:pPr>
             <a:r>
-              <a:rPr sz="1150" b="1">
+              <a:rPr b="1" sz="1150">
                 <a:solidFill>
                   <a:srgbClr val="10B981"/>
                 </a:solidFill>
@@ -7194,7 +7039,7 @@
               </a:spcBef>
             </a:pPr>
             <a:r>
-              <a:rPr sz="1150" b="1">
+              <a:rPr b="1" sz="1150">
                 <a:solidFill>
                   <a:srgbClr val="10B981"/>
                 </a:solidFill>
@@ -7217,7 +7062,7 @@
               </a:spcBef>
             </a:pPr>
             <a:r>
-              <a:rPr sz="1150" b="1">
+              <a:rPr b="1" sz="1150">
                 <a:solidFill>
                   <a:srgbClr val="10B981"/>
                 </a:solidFill>
@@ -7240,7 +7085,7 @@
               </a:spcBef>
             </a:pPr>
             <a:r>
-              <a:rPr sz="1150" b="1">
+              <a:rPr b="1" sz="1150">
                 <a:solidFill>
                   <a:srgbClr val="10B981"/>
                 </a:solidFill>
@@ -7300,7 +7145,6 @@
           <a:lstStyle/>
           <a:p>
             <a:pPr algn="ctr"/>
-            <a:endParaRPr/>
           </a:p>
         </p:txBody>
       </p:sp>
@@ -7344,7 +7188,6 @@
           <a:lstStyle/>
           <a:p>
             <a:pPr algn="ctr"/>
-            <a:endParaRPr/>
           </a:p>
         </p:txBody>
       </p:sp>
@@ -7387,7 +7230,7 @@
               </a:spcBef>
             </a:pPr>
             <a:r>
-              <a:rPr sz="1150" b="1">
+              <a:rPr b="1" sz="1150">
                 <a:solidFill>
                   <a:srgbClr val="EF4444"/>
                 </a:solidFill>
@@ -7410,7 +7253,7 @@
               </a:spcBef>
             </a:pPr>
             <a:r>
-              <a:rPr sz="1150" b="1">
+              <a:rPr b="1" sz="1150">
                 <a:solidFill>
                   <a:srgbClr val="EF4444"/>
                 </a:solidFill>
@@ -7433,7 +7276,7 @@
               </a:spcBef>
             </a:pPr>
             <a:r>
-              <a:rPr sz="1150" b="1">
+              <a:rPr b="1" sz="1150">
                 <a:solidFill>
                   <a:srgbClr val="EF4444"/>
                 </a:solidFill>
@@ -7456,7 +7299,7 @@
               </a:spcBef>
             </a:pPr>
             <a:r>
-              <a:rPr sz="1150" b="1">
+              <a:rPr b="1" sz="1150">
                 <a:solidFill>
                   <a:srgbClr val="EF4444"/>
                 </a:solidFill>

</xml_diff>